<commit_message>
fix(checkpoint-2): do layout bao cao bang metrics font that + tu validate khong tran
- src/build_checkpoint_report.py:
  - do chieu cao/so dong bang metrics that cua font (Pillow doc TTF Calibri/Consolas)
    -> wrap giong het PowerPoint, tu thu nho cu chung khi vuot khung
  - fill theo 'khung' (card) cua template: tieu de + than; kiem tra tran bang + kiem tra chong
  - noi khoi 'PROVENANCE'/'BLOCKER' + 'SCALE' de du chua nho
  - tham chieu TAG (khong phu thuoc HEAD) -> sinh lai bao cao cho ket qua giong het nhau
  - validate() tra exit code != 0 neu con tran/chong/thieu noi dung
- src/build_checkpoint_brief.py:
  - dieu 4 dong EXIT TICKET ngay tai cho (thay duong '____' cua mau) thay vi them muc rieng
  - them bang doi chieu rubric -> evidence + validate
- docs/*.pptx|docx: sinh lai theo layout moi

Khong sua 1 byte nao cua raw CSV 8,59 GB.
</commit_message>
<xml_diff>
--- a/docs/Checkpoint2_Report_YouTube_Trending.pptx
+++ b/docs/Checkpoint2_Report_YouTube_Trending.pptx
@@ -1411,7 +1411,7 @@
         <p:spPr>
           <a:xfrm>
             <a:off x="685800" y="2788920"/>
-            <a:ext cx="10058400" cy="329184"/>
+            <a:ext cx="6903720" cy="207465"/>
           </a:xfrm>
           <a:prstGeom prst="rect">
             <a:avLst/>
@@ -1429,7 +1429,7 @@
               <a:buNone/>
             </a:pPr>
             <a:r>
-              <a:rPr lang="en-US" sz="1400" dirty="0">
+              <a:rPr lang="en-US" sz="1300" dirty="0">
                 <a:solidFill>
                   <a:srgbClr val="D5E3EE"/>
                 </a:solidFill>
@@ -1452,7 +1452,7 @@
         <p:spPr>
           <a:xfrm>
             <a:off x="685800" y="3246120"/>
-            <a:ext cx="10058400" cy="329184"/>
+            <a:ext cx="6903720" cy="207465"/>
           </a:xfrm>
           <a:prstGeom prst="rect">
             <a:avLst/>
@@ -1470,7 +1470,7 @@
               <a:buNone/>
             </a:pPr>
             <a:r>
-              <a:rPr lang="en-US" sz="1400" dirty="0">
+              <a:rPr lang="en-US" sz="1300" dirty="0">
                 <a:solidFill>
                   <a:srgbClr val="D5E3EE"/>
                 </a:solidFill>
@@ -1493,7 +1493,7 @@
         <p:spPr>
           <a:xfrm>
             <a:off x="685800" y="3703320"/>
-            <a:ext cx="10058400" cy="329184"/>
+            <a:ext cx="6903720" cy="207465"/>
           </a:xfrm>
           <a:prstGeom prst="rect">
             <a:avLst/>
@@ -1511,7 +1511,7 @@
               <a:buNone/>
             </a:pPr>
             <a:r>
-              <a:rPr lang="en-US" sz="1400" dirty="0">
+              <a:rPr lang="en-US" sz="1300" dirty="0">
                 <a:solidFill>
                   <a:srgbClr val="D5E3EE"/>
                 </a:solidFill>
@@ -1519,7 +1519,7 @@
                 <a:ea typeface="Aptos" pitchFamily="34" charset="-122"/>
                 <a:cs typeface="Aptos" pitchFamily="34" charset="-120"/>
               </a:rPr>
-              <a:t>Git commit/tag: 2d80b55 · tag checkpoint-2 (445621b)</a:t>
+              <a:t>Git commit/tag: tag checkpoint-2 (be67019)</a:t>
             </a:r>
             <a:endParaRPr lang="en-US" sz="1700" dirty="0"/>
           </a:p>
@@ -1818,7 +1818,7 @@
         <p:spPr>
           <a:xfrm>
             <a:off x="941832" y="2011680"/>
-            <a:ext cx="10369296" cy="310896"/>
+            <a:ext cx="10369296" cy="175547"/>
           </a:xfrm>
           <a:prstGeom prst="rect">
             <a:avLst/>
@@ -1836,7 +1836,7 @@
               <a:buNone/>
             </a:pPr>
             <a:r>
-              <a:rPr lang="en-US" sz="1600" b="1" dirty="0">
+              <a:rPr lang="en-US" sz="1100" b="1" dirty="0">
                 <a:solidFill>
                   <a:srgbClr val="1D4ED8"/>
                 </a:solidFill>
@@ -1858,8 +1858,8 @@
         </p:nvSpPr>
         <p:spPr>
           <a:xfrm>
-            <a:off x="941832" y="2404872"/>
-            <a:ext cx="10369296" cy="2907792"/>
+            <a:off x="941832" y="2832506"/>
+            <a:ext cx="10369296" cy="2089101"/>
           </a:xfrm>
           <a:prstGeom prst="rect">
             <a:avLst/>
@@ -2092,7 +2092,7 @@
         <p:spPr>
           <a:xfrm>
             <a:off x="868680" y="5623560"/>
-            <a:ext cx="10241280" cy="310896"/>
+            <a:ext cx="10241280" cy="335135"/>
           </a:xfrm>
           <a:prstGeom prst="rect">
             <a:avLst/>
@@ -2348,8 +2348,8 @@
         </p:nvSpPr>
         <p:spPr>
           <a:xfrm>
-            <a:off x="941832" y="2359152"/>
-            <a:ext cx="4745736" cy="2770632"/>
+            <a:off x="941832" y="2959256"/>
+            <a:ext cx="4745736" cy="1607001"/>
           </a:xfrm>
           <a:prstGeom prst="rect">
             <a:avLst/>
@@ -2375,7 +2375,7 @@
                 <a:ea typeface="Aptos" pitchFamily="34" charset="-122"/>
                 <a:cs typeface="Aptos" pitchFamily="34" charset="-120"/>
               </a:rPr>
-              <a:t>Dán screenshot hoặc output (logs/env_check.txt):</a:t>
+              <a:t>Output logs/env_check.txt:</a:t>
             </a:r>
             <a:endParaRPr lang="en-US" sz="1300" dirty="0"/>
           </a:p>
@@ -2488,7 +2488,7 @@
                 <a:ea typeface="Aptos" pitchFamily="34" charset="-122"/>
                 <a:cs typeface="Aptos" pitchFamily="34" charset="-120"/>
               </a:rPr>
-              <a:t>  RESULT : PASS</a:t>
+              <a:t>  RESULT   : PASS</a:t>
             </a:r>
           </a:p>
           <a:p>
@@ -2601,8 +2601,8 @@
         </p:nvSpPr>
         <p:spPr>
           <a:xfrm>
-            <a:off x="6428232" y="2359152"/>
-            <a:ext cx="4745736" cy="438912"/>
+            <a:off x="6428232" y="2367324"/>
+            <a:ext cx="4745736" cy="459143"/>
           </a:xfrm>
           <a:prstGeom prst="rect">
             <a:avLst/>
@@ -2742,8 +2742,8 @@
         </p:nvSpPr>
         <p:spPr>
           <a:xfrm>
-            <a:off x="6428232" y="3776472"/>
-            <a:ext cx="4745736" cy="438912"/>
+            <a:off x="6428232" y="3926442"/>
+            <a:ext cx="4745736" cy="175547"/>
           </a:xfrm>
           <a:prstGeom prst="rect">
             <a:avLst/>
@@ -2784,7 +2784,7 @@
         <p:spPr>
           <a:xfrm>
             <a:off x="6263640" y="4663440"/>
-            <a:ext cx="5074920" cy="594360"/>
+            <a:ext cx="5074920" cy="960120"/>
           </a:xfrm>
           <a:prstGeom prst="roundRect">
             <a:avLst>
@@ -2851,8 +2851,8 @@
         </p:nvSpPr>
         <p:spPr>
           <a:xfrm>
-            <a:off x="6428232" y="5193792"/>
-            <a:ext cx="4745736" cy="-64008"/>
+            <a:off x="6428232" y="5166792"/>
+            <a:ext cx="4745736" cy="319176"/>
           </a:xfrm>
           <a:prstGeom prst="rect">
             <a:avLst/>
@@ -3108,8 +3108,8 @@
         </p:nvSpPr>
         <p:spPr>
           <a:xfrm>
-            <a:off x="941832" y="2359152"/>
-            <a:ext cx="4745736" cy="438912"/>
+            <a:off x="941832" y="2513112"/>
+            <a:ext cx="4745736" cy="167568"/>
           </a:xfrm>
           <a:prstGeom prst="rect">
             <a:avLst/>
@@ -3150,7 +3150,7 @@
         <p:spPr>
           <a:xfrm>
             <a:off x="777240" y="3246120"/>
-            <a:ext cx="5074920" cy="1097280"/>
+            <a:ext cx="5074920" cy="1188720"/>
           </a:xfrm>
           <a:prstGeom prst="roundRect">
             <a:avLst>
@@ -3217,8 +3217,8 @@
         </p:nvSpPr>
         <p:spPr>
           <a:xfrm>
-            <a:off x="941832" y="3776472"/>
-            <a:ext cx="4745736" cy="438912"/>
+            <a:off x="941832" y="3820554"/>
+            <a:ext cx="4745736" cy="478765"/>
           </a:xfrm>
           <a:prstGeom prst="rect">
             <a:avLst/>
@@ -3291,7 +3291,7 @@
         <p:spPr>
           <a:xfrm>
             <a:off x="777240" y="4663440"/>
-            <a:ext cx="5074920" cy="685800"/>
+            <a:ext cx="5074920" cy="960120"/>
           </a:xfrm>
           <a:prstGeom prst="roundRect">
             <a:avLst>
@@ -3358,8 +3358,8 @@
         </p:nvSpPr>
         <p:spPr>
           <a:xfrm>
-            <a:off x="941832" y="5193792"/>
-            <a:ext cx="4745736" cy="27432"/>
+            <a:off x="941832" y="5166792"/>
+            <a:ext cx="4745736" cy="319176"/>
           </a:xfrm>
           <a:prstGeom prst="rect">
             <a:avLst/>
@@ -3385,7 +3385,7 @@
                 <a:ea typeface="Aptos" pitchFamily="34" charset="-122"/>
                 <a:cs typeface="Aptos" pitchFamily="34" charset="-120"/>
               </a:rPr>
-              <a:t>Nguồn: Kaggle · license ODC-By · file gốc giữ ngoài repo, ingest = copy + hash + manifest (bytes, sha256, thời điểm) → truy ngược được từng byte trong raw.</a:t>
+              <a:t>Nguồn: Kaggle · license ODC-By · file gốc giữ ngoài repo; ingest = copy + hash + manifest → truy ngược được từng byte trong raw.</a:t>
             </a:r>
             <a:endParaRPr lang="en-US" sz="1300" dirty="0"/>
           </a:p>
@@ -3467,8 +3467,8 @@
         </p:nvSpPr>
         <p:spPr>
           <a:xfrm>
-            <a:off x="6428232" y="2359152"/>
-            <a:ext cx="4745736" cy="2862072"/>
+            <a:off x="6428232" y="3349333"/>
+            <a:ext cx="4745736" cy="918286"/>
           </a:xfrm>
           <a:prstGeom prst="rect">
             <a:avLst/>
@@ -3559,7 +3559,7 @@
                 <a:ea typeface="Aptos" pitchFamily="34" charset="-122"/>
                 <a:cs typeface="Aptos" pitchFamily="34" charset="-120"/>
               </a:rPr>
-              <a:t>  success | dataset=youtube_trending | run=run_20261020T143013Z | files=1</a:t>
+              <a:t>  success | files=1 | bytes=8591418141 | sha256=4310930bd2d1…</a:t>
             </a:r>
           </a:p>
           <a:p>
@@ -3575,23 +3575,7 @@
                 <a:ea typeface="Aptos" pitchFamily="34" charset="-122"/>
                 <a:cs typeface="Aptos" pitchFamily="34" charset="-120"/>
               </a:rPr>
-              <a:t>          | bytes=8591418141 | sha256=4310930bd2d1… | status=success</a:t>
-            </a:r>
-          </a:p>
-          <a:p>
-            <a:pPr algn="l" indent="0" marL="0">
-              <a:buNone/>
-            </a:pPr>
-            <a:r>
-              <a:rPr lang="en-US" sz="1000" dirty="0">
-                <a:solidFill>
-                  <a:srgbClr val="5B6B7A"/>
-                </a:solidFill>
-                <a:latin typeface="Consolas" pitchFamily="34" charset="0"/>
-                <a:ea typeface="Aptos" pitchFamily="34" charset="-122"/>
-                <a:cs typeface="Aptos" pitchFamily="34" charset="-120"/>
-              </a:rPr>
-              <a:t>  manifest | data\raw\youtube_trending\…\manifest.json</a:t>
+              <a:t>  run=run_20261020T143013Z | status=success | manifest ghi ra raw/</a:t>
             </a:r>
           </a:p>
         </p:txBody>
@@ -3753,7 +3737,7 @@
         <p:spPr>
           <a:xfrm>
             <a:off x="777240" y="1828800"/>
-            <a:ext cx="5074920" cy="3520440"/>
+            <a:ext cx="5486400" cy="3520440"/>
           </a:xfrm>
           <a:prstGeom prst="roundRect">
             <a:avLst>
@@ -3820,8 +3804,8 @@
         </p:nvSpPr>
         <p:spPr>
           <a:xfrm>
-            <a:off x="941832" y="2359152"/>
-            <a:ext cx="4745736" cy="2862072"/>
+            <a:off x="941832" y="3081499"/>
+            <a:ext cx="5212080" cy="1453953"/>
           </a:xfrm>
           <a:prstGeom prst="rect">
             <a:avLst/>
@@ -3839,7 +3823,7 @@
               <a:buNone/>
             </a:pPr>
             <a:r>
-              <a:rPr lang="en-US" sz="1050" dirty="0">
+              <a:rPr lang="en-US" sz="950" dirty="0">
                 <a:solidFill>
                   <a:srgbClr val="5B6B7A"/>
                 </a:solidFill>
@@ -3856,23 +3840,23 @@
               <a:buNone/>
             </a:pPr>
             <a:r>
-              <a:rPr lang="en-US" sz="1050" dirty="0">
-                <a:solidFill>
-                  <a:srgbClr val="5B6B7A"/>
-                </a:solidFill>
-                <a:latin typeface="Consolas" pitchFamily="34" charset="0"/>
-                <a:ea typeface="Aptos" pitchFamily="34" charset="-122"/>
-                <a:cs typeface="Aptos" pitchFamily="34" charset="-120"/>
-              </a:rPr>
-              <a:t>  data/raw/&lt;dataset&gt;/ingest_date=YYYY-MM-DD/run_&lt;UTC_TIMESTAMP&gt;/</a:t>
-            </a:r>
-          </a:p>
-          <a:p>
-            <a:pPr algn="l" indent="0" marL="0">
-              <a:buNone/>
-            </a:pPr>
-            <a:r>
-              <a:rPr lang="en-US" sz="1050" dirty="0">
+              <a:rPr lang="en-US" sz="950" dirty="0">
+                <a:solidFill>
+                  <a:srgbClr val="5B6B7A"/>
+                </a:solidFill>
+                <a:latin typeface="Consolas" pitchFamily="34" charset="0"/>
+                <a:ea typeface="Aptos" pitchFamily="34" charset="-122"/>
+                <a:cs typeface="Aptos" pitchFamily="34" charset="-120"/>
+              </a:rPr>
+              <a:t>  data/raw/&lt;dataset&gt;/ingest_date=YYYY-MM-DD/run_&lt;UTC&gt;/</a:t>
+            </a:r>
+          </a:p>
+          <a:p>
+            <a:pPr algn="l" indent="0" marL="0">
+              <a:buNone/>
+            </a:pPr>
+            <a:r>
+              <a:rPr lang="en-US" sz="950" dirty="0">
                 <a:solidFill>
                   <a:srgbClr val="5B6B7A"/>
                 </a:solidFill>
@@ -3888,55 +3872,87 @@
               <a:buNone/>
             </a:pPr>
             <a:r>
-              <a:rPr lang="en-US" sz="1050" dirty="0">
-                <a:solidFill>
-                  <a:srgbClr val="5B6B7A"/>
-                </a:solidFill>
-                <a:latin typeface="Consolas" pitchFamily="34" charset="0"/>
-                <a:ea typeface="Aptos" pitchFamily="34" charset="-122"/>
-                <a:cs typeface="Aptos" pitchFamily="34" charset="-120"/>
-              </a:rPr>
-              <a:t>  data/raw/youtube_trending/ingest_date=2026-10-20/run_20261020T143013Z/</a:t>
-            </a:r>
-          </a:p>
-          <a:p>
-            <a:pPr algn="l" indent="0" marL="0">
-              <a:buNone/>
-            </a:pPr>
-            <a:r>
-              <a:rPr lang="en-US" sz="1050" dirty="0">
-                <a:solidFill>
-                  <a:srgbClr val="5B6B7A"/>
-                </a:solidFill>
-                <a:latin typeface="Consolas" pitchFamily="34" charset="0"/>
-                <a:ea typeface="Aptos" pitchFamily="34" charset="-122"/>
-                <a:cs typeface="Aptos" pitchFamily="34" charset="-120"/>
-              </a:rPr>
-              <a:t>    ├─ trending_yt_videos_113_countries.csv   (8.591.418.141 bytes)</a:t>
-            </a:r>
-          </a:p>
-          <a:p>
-            <a:pPr algn="l" indent="0" marL="0">
-              <a:buNone/>
-            </a:pPr>
-            <a:r>
-              <a:rPr lang="en-US" sz="1050" dirty="0">
-                <a:solidFill>
-                  <a:srgbClr val="5B6B7A"/>
-                </a:solidFill>
-                <a:latin typeface="Consolas" pitchFamily="34" charset="0"/>
-                <a:ea typeface="Aptos" pitchFamily="34" charset="-122"/>
-                <a:cs typeface="Aptos" pitchFamily="34" charset="-120"/>
-              </a:rPr>
-              <a:t>    └─ manifest.json                          (status: success)</a:t>
-            </a:r>
-          </a:p>
-          <a:p>
-            <a:pPr algn="l" indent="0" marL="0">
-              <a:buNone/>
-            </a:pPr>
-            <a:r>
-              <a:rPr lang="en-US" sz="1050" dirty="0">
+              <a:rPr lang="en-US" sz="950" dirty="0">
+                <a:solidFill>
+                  <a:srgbClr val="5B6B7A"/>
+                </a:solidFill>
+                <a:latin typeface="Consolas" pitchFamily="34" charset="0"/>
+                <a:ea typeface="Aptos" pitchFamily="34" charset="-122"/>
+                <a:cs typeface="Aptos" pitchFamily="34" charset="-120"/>
+              </a:rPr>
+              <a:t>  data/raw/youtube_trending/</a:t>
+            </a:r>
+          </a:p>
+          <a:p>
+            <a:pPr algn="l" indent="0" marL="0">
+              <a:buNone/>
+            </a:pPr>
+            <a:r>
+              <a:rPr lang="en-US" sz="950" dirty="0">
+                <a:solidFill>
+                  <a:srgbClr val="5B6B7A"/>
+                </a:solidFill>
+                <a:latin typeface="Consolas" pitchFamily="34" charset="0"/>
+                <a:ea typeface="Aptos" pitchFamily="34" charset="-122"/>
+                <a:cs typeface="Aptos" pitchFamily="34" charset="-120"/>
+              </a:rPr>
+              <a:t>    ingest_date=2026-10-20/</a:t>
+            </a:r>
+          </a:p>
+          <a:p>
+            <a:pPr algn="l" indent="0" marL="0">
+              <a:buNone/>
+            </a:pPr>
+            <a:r>
+              <a:rPr lang="en-US" sz="950" dirty="0">
+                <a:solidFill>
+                  <a:srgbClr val="5B6B7A"/>
+                </a:solidFill>
+                <a:latin typeface="Consolas" pitchFamily="34" charset="0"/>
+                <a:ea typeface="Aptos" pitchFamily="34" charset="-122"/>
+                <a:cs typeface="Aptos" pitchFamily="34" charset="-120"/>
+              </a:rPr>
+              <a:t>      run_20261020T143013Z/</a:t>
+            </a:r>
+          </a:p>
+          <a:p>
+            <a:pPr algn="l" indent="0" marL="0">
+              <a:buNone/>
+            </a:pPr>
+            <a:r>
+              <a:rPr lang="en-US" sz="950" dirty="0">
+                <a:solidFill>
+                  <a:srgbClr val="5B6B7A"/>
+                </a:solidFill>
+                <a:latin typeface="Consolas" pitchFamily="34" charset="0"/>
+                <a:ea typeface="Aptos" pitchFamily="34" charset="-122"/>
+                <a:cs typeface="Aptos" pitchFamily="34" charset="-120"/>
+              </a:rPr>
+              <a:t>        ├─ trending_yt_videos_113_countries.csv (8.591.418.141 bytes)</a:t>
+            </a:r>
+          </a:p>
+          <a:p>
+            <a:pPr algn="l" indent="0" marL="0">
+              <a:buNone/>
+            </a:pPr>
+            <a:r>
+              <a:rPr lang="en-US" sz="950" dirty="0">
+                <a:solidFill>
+                  <a:srgbClr val="5B6B7A"/>
+                </a:solidFill>
+                <a:latin typeface="Consolas" pitchFamily="34" charset="0"/>
+                <a:ea typeface="Aptos" pitchFamily="34" charset="-122"/>
+                <a:cs typeface="Aptos" pitchFamily="34" charset="-120"/>
+              </a:rPr>
+              <a:t>        └─ manifest.json                        (status: success)</a:t>
+            </a:r>
+          </a:p>
+          <a:p>
+            <a:pPr algn="l" indent="0" marL="0">
+              <a:buNone/>
+            </a:pPr>
+            <a:r>
+              <a:rPr lang="en-US" sz="950" dirty="0">
                 <a:solidFill>
                   <a:srgbClr val="5B6B7A"/>
                 </a:solidFill>
@@ -3952,7 +3968,7 @@
               <a:buNone/>
             </a:pPr>
             <a:r>
-              <a:rPr lang="en-US" sz="1050" dirty="0">
+              <a:rPr lang="en-US" sz="950" dirty="0">
                 <a:solidFill>
                   <a:srgbClr val="5B6B7A"/>
                 </a:solidFill>
@@ -4041,8 +4057,8 @@
         </p:nvSpPr>
         <p:spPr>
           <a:xfrm>
-            <a:off x="6428232" y="2359152"/>
-            <a:ext cx="4745736" cy="2862072"/>
+            <a:off x="6428232" y="2890190"/>
+            <a:ext cx="4745736" cy="1836572"/>
           </a:xfrm>
           <a:prstGeom prst="rect">
             <a:avLst/>
@@ -4198,6 +4214,22 @@
                 <a:cs typeface="Aptos" pitchFamily="34" charset="-120"/>
               </a:rPr>
               <a:t>  status        : success</a:t>
+            </a:r>
+          </a:p>
+          <a:p>
+            <a:pPr algn="l" indent="0" marL="0">
+              <a:buNone/>
+            </a:pPr>
+            <a:r>
+              <a:rPr lang="en-US" sz="1000" dirty="0">
+                <a:solidFill>
+                  <a:srgbClr val="5B6B7A"/>
+                </a:solidFill>
+                <a:latin typeface="Consolas" pitchFamily="34" charset="0"/>
+                <a:ea typeface="Aptos" pitchFamily="34" charset="-122"/>
+                <a:cs typeface="Aptos" pitchFamily="34" charset="-120"/>
+              </a:rPr>
+              <a:t>  amendments[]  : 1 (ghi mọi thay đổi metadata, kèm mốc thời gian)</a:t>
             </a:r>
           </a:p>
           <a:p>
@@ -4391,7 +4423,7 @@
         <p:spPr>
           <a:xfrm>
             <a:off x="777240" y="1828800"/>
-            <a:ext cx="5074920" cy="1325880"/>
+            <a:ext cx="5074920" cy="1417320"/>
           </a:xfrm>
           <a:prstGeom prst="roundRect">
             <a:avLst>
@@ -4458,8 +4490,8 @@
         </p:nvSpPr>
         <p:spPr>
           <a:xfrm>
-            <a:off x="941832" y="2359152"/>
-            <a:ext cx="4745736" cy="667512"/>
+            <a:off x="941832" y="2393428"/>
+            <a:ext cx="4745736" cy="726977"/>
           </a:xfrm>
           <a:prstGeom prst="rect">
             <a:avLst/>
@@ -4502,7 +4534,7 @@
                 <a:ea typeface="Aptos" pitchFamily="34" charset="-122"/>
                 <a:cs typeface="Aptos" pitchFamily="34" charset="-120"/>
               </a:rPr>
-              <a:t>  lần 1  → tạo run_… + copy + manifest</a:t>
+              <a:t>  lần 1   → tạo run_… + copy + manifest</a:t>
             </a:r>
           </a:p>
           <a:p>
@@ -4534,7 +4566,23 @@
                 <a:ea typeface="Aptos" pitchFamily="34" charset="-122"/>
                 <a:cs typeface="Aptos" pitchFamily="34" charset="-120"/>
               </a:rPr>
-              <a:t>hash khác → run_id mới (append, không overwrite) | nguồn hỏng → fail-fast</a:t>
+              <a:t>hash khác → run_id mới (append, không overwrite)</a:t>
+            </a:r>
+          </a:p>
+          <a:p>
+            <a:pPr algn="l" indent="0" marL="0">
+              <a:buNone/>
+            </a:pPr>
+            <a:r>
+              <a:rPr lang="en-US" sz="950" dirty="0">
+                <a:solidFill>
+                  <a:srgbClr val="5B6B7A"/>
+                </a:solidFill>
+                <a:latin typeface="Consolas" pitchFamily="34" charset="0"/>
+                <a:ea typeface="Aptos" pitchFamily="34" charset="-122"/>
+                <a:cs typeface="Aptos" pitchFamily="34" charset="-120"/>
+              </a:rPr>
+              <a:t>nguồn hỏng → fail-fast (exit 1), không tạo raw giả</a:t>
             </a:r>
           </a:p>
         </p:txBody>
@@ -4548,7 +4596,7 @@
         <p:spPr>
           <a:xfrm>
             <a:off x="777240" y="3493008"/>
-            <a:ext cx="5074920" cy="1325880"/>
+            <a:ext cx="5074920" cy="1417320"/>
           </a:xfrm>
           <a:prstGeom prst="roundRect">
             <a:avLst>
@@ -4615,8 +4663,8 @@
         </p:nvSpPr>
         <p:spPr>
           <a:xfrm>
-            <a:off x="941832" y="4023360"/>
-            <a:ext cx="4745736" cy="667512"/>
+            <a:off x="941832" y="4062051"/>
+            <a:ext cx="4745736" cy="718147"/>
           </a:xfrm>
           <a:prstGeom prst="rect">
             <a:avLst/>
@@ -4634,7 +4682,7 @@
               <a:buNone/>
             </a:pPr>
             <a:r>
-              <a:rPr lang="en-US" sz="950" dirty="0">
+              <a:rPr lang="en-US" sz="900" dirty="0">
                 <a:solidFill>
                   <a:srgbClr val="5B6B7A"/>
                 </a:solidFill>
@@ -4651,7 +4699,7 @@
               <a:buNone/>
             </a:pPr>
             <a:r>
-              <a:rPr lang="en-US" sz="950" dirty="0">
+              <a:rPr lang="en-US" sz="900" dirty="0">
                 <a:solidFill>
                   <a:srgbClr val="5B6B7A"/>
                 </a:solidFill>
@@ -4667,7 +4715,7 @@
               <a:buNone/>
             </a:pPr>
             <a:r>
-              <a:rPr lang="en-US" sz="950" dirty="0">
+              <a:rPr lang="en-US" sz="900" dirty="0">
                 <a:solidFill>
                   <a:srgbClr val="5B6B7A"/>
                 </a:solidFill>
@@ -4689,7 +4737,7 @@
         <p:spPr>
           <a:xfrm>
             <a:off x="6263640" y="1828800"/>
-            <a:ext cx="5074920" cy="1325880"/>
+            <a:ext cx="5074920" cy="1417320"/>
           </a:xfrm>
           <a:prstGeom prst="roundRect">
             <a:avLst>
@@ -4756,8 +4804,8 @@
         </p:nvSpPr>
         <p:spPr>
           <a:xfrm>
-            <a:off x="6428232" y="2359152"/>
-            <a:ext cx="4745736" cy="667512"/>
+            <a:off x="6428232" y="2538823"/>
+            <a:ext cx="4745736" cy="436186"/>
           </a:xfrm>
           <a:prstGeom prst="rect">
             <a:avLst/>
@@ -4783,7 +4831,7 @@
                 <a:ea typeface="Aptos" pitchFamily="34" charset="-122"/>
                 <a:cs typeface="Aptos" pitchFamily="34" charset="-120"/>
               </a:rPr>
-              <a:t>Commit/tag: 2d80b55 · tag checkpoint-2 (445621b)</a:t>
+              <a:t>Commit/tag: tag checkpoint-2 (be67019)</a:t>
             </a:r>
             <a:endParaRPr lang="en-US" sz="1300" dirty="0"/>
           </a:p>
@@ -4800,7 +4848,23 @@
                 <a:ea typeface="Aptos" pitchFamily="34" charset="-122"/>
                 <a:cs typeface="Aptos" pitchFamily="34" charset="-120"/>
               </a:rPr>
-              <a:t>Raw/manifest/log: data/raw/youtube_trending/…/run_…/manifest.json · logs/*.log</a:t>
+              <a:t>Raw/manifest/log: data/raw/youtube_trending/…/run_…/manifest.json</a:t>
+            </a:r>
+          </a:p>
+          <a:p>
+            <a:pPr algn="l" indent="0" marL="0">
+              <a:buNone/>
+            </a:pPr>
+            <a:r>
+              <a:rPr lang="en-US" sz="950" dirty="0">
+                <a:solidFill>
+                  <a:srgbClr val="5B6B7A"/>
+                </a:solidFill>
+                <a:latin typeface="Consolas" pitchFamily="34" charset="0"/>
+                <a:ea typeface="Aptos" pitchFamily="34" charset="-122"/>
+                <a:cs typeface="Aptos" pitchFamily="34" charset="-120"/>
+              </a:rPr>
+              <a:t>logs/env_check.txt · logs/ingest.log · logs/transform.log</a:t>
             </a:r>
           </a:p>
         </p:txBody>
@@ -4814,7 +4878,7 @@
         <p:spPr>
           <a:xfrm>
             <a:off x="6263640" y="3493008"/>
-            <a:ext cx="5074920" cy="1325880"/>
+            <a:ext cx="5074920" cy="1417320"/>
           </a:xfrm>
           <a:prstGeom prst="roundRect">
             <a:avLst>
@@ -4881,8 +4945,8 @@
         </p:nvSpPr>
         <p:spPr>
           <a:xfrm>
-            <a:off x="6428232" y="4023360"/>
-            <a:ext cx="4745736" cy="667512"/>
+            <a:off x="6428232" y="4269515"/>
+            <a:ext cx="4745736" cy="303218"/>
           </a:xfrm>
           <a:prstGeom prst="rect">
             <a:avLst/>

</xml_diff>

<commit_message>
docs(checkpoint-2): dong bo commit hash cua tag checkpoint-2 trong noi dung 6 slide
</commit_message>
<xml_diff>
--- a/docs/Checkpoint2_Report_YouTube_Trending.pptx
+++ b/docs/Checkpoint2_Report_YouTube_Trending.pptx
@@ -1519,7 +1519,7 @@
                 <a:ea typeface="Aptos" pitchFamily="34" charset="-122"/>
                 <a:cs typeface="Aptos" pitchFamily="34" charset="-120"/>
               </a:rPr>
-              <a:t>Git commit/tag: tag checkpoint-2 (be67019)</a:t>
+              <a:t>Git commit/tag: tag checkpoint-2 (1cd9bca)</a:t>
             </a:r>
             <a:endParaRPr lang="en-US" sz="1700" dirty="0"/>
           </a:p>
@@ -4831,7 +4831,7 @@
                 <a:ea typeface="Aptos" pitchFamily="34" charset="-122"/>
                 <a:cs typeface="Aptos" pitchFamily="34" charset="-120"/>
               </a:rPr>
-              <a:t>Commit/tag: tag checkpoint-2 (be67019)</a:t>
+              <a:t>Commit/tag: tag checkpoint-2 (1cd9bca)</a:t>
             </a:r>
             <a:endParaRPr lang="en-US" sz="1300" dirty="0"/>
           </a:p>

</xml_diff>

<commit_message>
refactor(checkpoint-2): bao cao tham chieu TAG (khong phu thuoc HEAD) de sinh lai idempotent
- PPTX/DOCX chi ghi 'tag checkpoint-2' + lenh 'git log -1 checkpoint-2'
  -> tag co the tro toi commit cuoi cung ma noi dung bao cao van dung
- validate() bo phu thuoc commit hash, giu kiem tra noi dung bat buoc
- docs/checkpoint2_slides_noidung.md: cung dung tag thay vi commit hard-code
</commit_message>
<xml_diff>
--- a/docs/Checkpoint2_Report_YouTube_Trending.pptx
+++ b/docs/Checkpoint2_Report_YouTube_Trending.pptx
@@ -1519,7 +1519,7 @@
                 <a:ea typeface="Aptos" pitchFamily="34" charset="-122"/>
                 <a:cs typeface="Aptos" pitchFamily="34" charset="-120"/>
               </a:rPr>
-              <a:t>Git commit/tag: tag checkpoint-2 (1cd9bca)</a:t>
+              <a:t>Git commit/tag: tag checkpoint-2  (git log -1 checkpoint-2)</a:t>
             </a:r>
             <a:endParaRPr lang="en-US" sz="1700" dirty="0"/>
           </a:p>
@@ -4831,7 +4831,7 @@
                 <a:ea typeface="Aptos" pitchFamily="34" charset="-122"/>
                 <a:cs typeface="Aptos" pitchFamily="34" charset="-120"/>
               </a:rPr>
-              <a:t>Commit/tag: tag checkpoint-2 (1cd9bca)</a:t>
+              <a:t>Commit/tag: tag checkpoint-2  (git log -1 checkpoint-2)</a:t>
             </a:r>
             <a:endParaRPr lang="en-US" sz="1300" dirty="0"/>
           </a:p>

</xml_diff>

<commit_message>
docs(checkpoint-2): slide 5 ghi ro tool do so record (verify_raw_records.py) + validate them noi dung
</commit_message>
<xml_diff>
--- a/docs/Checkpoint2_Report_YouTube_Trending.pptx
+++ b/docs/Checkpoint2_Report_YouTube_Trending.pptx
@@ -4057,8 +4057,8 @@
         </p:nvSpPr>
         <p:spPr>
           <a:xfrm>
-            <a:off x="6428232" y="2890190"/>
-            <a:ext cx="4745736" cy="1836572"/>
+            <a:off x="6428232" y="2813666"/>
+            <a:ext cx="4745736" cy="1989620"/>
           </a:xfrm>
           <a:prstGeom prst="rect">
             <a:avLst/>
@@ -4262,6 +4262,22 @@
                 <a:cs typeface="Aptos" pitchFamily="34" charset="-120"/>
               </a:rPr>
               <a:t>Log: logs/env_check.txt · logs/ingest.log · logs/transform.log</a:t>
+            </a:r>
+          </a:p>
+          <a:p>
+            <a:pPr algn="l" indent="0" marL="0">
+              <a:buNone/>
+            </a:pPr>
+            <a:r>
+              <a:rPr lang="en-US" sz="1000" dirty="0">
+                <a:solidFill>
+                  <a:srgbClr val="5B6B7A"/>
+                </a:solidFill>
+                <a:latin typeface="Consolas" pitchFamily="34" charset="0"/>
+                <a:ea typeface="Aptos" pitchFamily="34" charset="-122"/>
+                <a:cs typeface="Aptos" pitchFamily="34" charset="-120"/>
+              </a:rPr>
+              <a:t>Đếm record: src/verify_raw_records.py (chuẩn RFC4180, 86,7 s)</a:t>
             </a:r>
           </a:p>
         </p:txBody>

</xml_diff>

<commit_message>
feat: add ingestion, transformation, verification, and dashboard scripts for YouTube Trending dataset
</commit_message>
<xml_diff>
--- a/docs/Checkpoint2_Report_YouTube_Trending.pptx
+++ b/docs/Checkpoint2_Report_YouTube_Trending.pptx
@@ -1329,7 +1329,7 @@
         <p:spPr>
           <a:xfrm>
             <a:off x="685800" y="1051560"/>
-            <a:ext cx="8046720" cy="457200"/>
+            <a:ext cx="10058400" cy="457200"/>
           </a:xfrm>
           <a:prstGeom prst="rect">
             <a:avLst/>
@@ -1347,15 +1347,15 @@
               <a:buNone/>
             </a:pPr>
             <a:r>
-              <a:rPr lang="en-US" sz="1900" b="1" dirty="0">
-                <a:solidFill>
-                  <a:srgbClr val="9EDDEA"/>
+              <a:rPr lang="en-US" sz="1300" b="0" dirty="0">
+                <a:solidFill>
+                  <a:srgbClr val="D5E3EE"/>
                 </a:solidFill>
                 <a:latin typeface="Calibri" pitchFamily="34" charset="0"/>
                 <a:ea typeface="Calibri" pitchFamily="34" charset="-122"/>
                 <a:cs typeface="Calibri" pitchFamily="34" charset="-120"/>
               </a:rPr>
-              <a:t>ĐỒ ÁN 2 • CHECKPOINT REPORT</a:t>
+              <a:t>ĐỒ ÁN 2 • CHECKPOINT 2</a:t>
             </a:r>
             <a:endParaRPr lang="en-US" sz="1900" dirty="0"/>
           </a:p>
@@ -1411,7 +1411,7 @@
         <p:spPr>
           <a:xfrm>
             <a:off x="685800" y="2788920"/>
-            <a:ext cx="6812280" cy="254566"/>
+            <a:ext cx="10058400" cy="274320"/>
           </a:xfrm>
           <a:prstGeom prst="rect">
             <a:avLst/>
@@ -1437,7 +1437,7 @@
                 <a:ea typeface="Calibri" pitchFamily="34" charset="-122"/>
                 <a:cs typeface="Calibri" pitchFamily="34" charset="-120"/>
               </a:rPr>
-              <a:t>Nhóm: YouTube Trending Analytics  ·  4 thành viên</a:t>
+              <a:t>Nhóm: YouTube Trending Analytics</a:t>
             </a:r>
             <a:endParaRPr lang="en-US" sz="1700" dirty="0"/>
           </a:p>
@@ -1452,7 +1452,7 @@
         <p:spPr>
           <a:xfrm>
             <a:off x="685800" y="3246120"/>
-            <a:ext cx="6812280" cy="254566"/>
+            <a:ext cx="10058400" cy="274320"/>
           </a:xfrm>
           <a:prstGeom prst="rect">
             <a:avLst/>
@@ -1493,7 +1493,7 @@
         <p:spPr>
           <a:xfrm>
             <a:off x="685800" y="3703320"/>
-            <a:ext cx="6812280" cy="254566"/>
+            <a:ext cx="10058400" cy="274320"/>
           </a:xfrm>
           <a:prstGeom prst="rect">
             <a:avLst/>
@@ -1519,7 +1519,7 @@
                 <a:ea typeface="Calibri" pitchFamily="34" charset="-122"/>
                 <a:cs typeface="Calibri" pitchFamily="34" charset="-120"/>
               </a:rPr>
-              <a:t>Git commit/tag: tag checkpoint-2   (git log -1 checkpoint-2)</a:t>
+              <a:t>Tag: checkpoint-2</a:t>
             </a:r>
             <a:endParaRPr lang="en-US" sz="1700" dirty="0"/>
           </a:p>
@@ -1527,116 +1527,7 @@
       </p:sp>
       <p:sp>
         <p:nvSpPr>
-          <p:cNvPr id="7" name="Shape 5"/>
-          <p:cNvSpPr/>
-          <p:nvPr/>
-        </p:nvSpPr>
-        <p:spPr>
-          <a:xfrm>
-            <a:off x="7680960" y="2331720"/>
-            <a:ext cx="3383280" cy="2011680"/>
-          </a:xfrm>
-          <a:prstGeom prst="roundRect">
-            <a:avLst>
-              <a:gd name="adj" fmla="val 2273"/>
-            </a:avLst>
-          </a:prstGeom>
-          <a:solidFill>
-            <a:srgbClr val="FFFFFF"/>
-          </a:solidFill>
-          <a:ln w="15240">
-            <a:solidFill>
-              <a:srgbClr val="06B6D4"/>
-            </a:solidFill>
-            <a:prstDash val="solid"/>
-          </a:ln>
-        </p:spPr>
-      </p:sp>
-      <p:sp>
-        <p:nvSpPr>
-          <p:cNvPr id="8" name="Text 6"/>
-          <p:cNvSpPr/>
-          <p:nvPr/>
-        </p:nvSpPr>
-        <p:spPr>
-          <a:xfrm>
-            <a:off x="7845552" y="2468880"/>
-            <a:ext cx="3054096" cy="310896"/>
-          </a:xfrm>
-          <a:prstGeom prst="rect">
-            <a:avLst/>
-          </a:prstGeom>
-          <a:noFill/>
-          <a:ln/>
-        </p:spPr>
-        <p:txBody>
-          <a:bodyPr wrap="square" lIns="0" tIns="0" rIns="0" bIns="0" rtlCol="0" anchor="ctr">
-            <a:normAutofit/>
-          </a:bodyPr>
-          <a:lstStyle/>
-          <a:p>
-            <a:pPr algn="l" indent="0" marL="0">
-              <a:buNone/>
-            </a:pPr>
-            <a:r>
-              <a:rPr lang="en-US" sz="1600" b="1" dirty="0">
-                <a:solidFill>
-                  <a:srgbClr val="06B6D4"/>
-                </a:solidFill>
-                <a:latin typeface="Calibri" pitchFamily="34" charset="0"/>
-                <a:ea typeface="Calibri" pitchFamily="34" charset="-122"/>
-                <a:cs typeface="Calibri" pitchFamily="34" charset="-120"/>
-              </a:rPr>
-              <a:t>QUY TẮC</a:t>
-            </a:r>
-            <a:endParaRPr lang="en-US" sz="1600" dirty="0"/>
-          </a:p>
-        </p:txBody>
-      </p:sp>
-      <p:sp>
-        <p:nvSpPr>
-          <p:cNvPr id="9" name="Text 7"/>
-          <p:cNvSpPr/>
-          <p:nvPr/>
-        </p:nvSpPr>
-        <p:spPr>
-          <a:xfrm>
-            <a:off x="7845552" y="2862072"/>
-            <a:ext cx="3054096" cy="1353312"/>
-          </a:xfrm>
-          <a:prstGeom prst="rect">
-            <a:avLst/>
-          </a:prstGeom>
-          <a:noFill/>
-          <a:ln/>
-        </p:spPr>
-        <p:txBody>
-          <a:bodyPr wrap="square" lIns="0" tIns="0" rIns="0" bIns="0" rtlCol="0" anchor="ctr">
-            <a:normAutofit/>
-          </a:bodyPr>
-          <a:lstStyle/>
-          <a:p>
-            <a:pPr algn="l" indent="0" marL="0">
-              <a:buNone/>
-            </a:pPr>
-            <a:r>
-              <a:rPr lang="en-US" sz="1300" dirty="0">
-                <a:solidFill>
-                  <a:srgbClr val="5B6B7A"/>
-                </a:solidFill>
-                <a:latin typeface="Calibri" pitchFamily="34" charset="0"/>
-                <a:ea typeface="Calibri" pitchFamily="34" charset="-122"/>
-                <a:cs typeface="Calibri" pitchFamily="34" charset="-120"/>
-              </a:rPr>
-              <a:t>Tối đa 4 phút. Mỗi slide phải có evidence: terminal, repo, raw file, manifest hoặc log.</a:t>
-            </a:r>
-            <a:endParaRPr lang="en-US" sz="1300" dirty="0"/>
-          </a:p>
-        </p:txBody>
-      </p:sp>
-      <p:sp>
-        <p:nvSpPr>
-          <p:cNvPr id="10" name="Rule 1"/>
+          <p:cNvPr id="7" name="Rectangle 6"/>
           <p:cNvSpPr/>
           <p:nvPr/>
         </p:nvSpPr>
@@ -1666,7 +1557,7 @@
       </p:sp>
       <p:sp>
         <p:nvSpPr>
-          <p:cNvPr id="11" name="Footer 1"/>
+          <p:cNvPr id="8" name="TextBox 7"/>
           <p:cNvSpPr txBox="1"/>
           <p:nvPr/>
         </p:nvSpPr>
@@ -1807,55 +1698,14 @@
       </p:sp>
       <p:sp>
         <p:nvSpPr>
-          <p:cNvPr id="4" name="Text 2"/>
-          <p:cNvSpPr/>
-          <p:nvPr/>
-        </p:nvSpPr>
-        <p:spPr>
-          <a:xfrm>
-            <a:off x="594360" y="1261872"/>
-            <a:ext cx="10972800" cy="310896"/>
-          </a:xfrm>
-          <a:prstGeom prst="rect">
-            <a:avLst/>
-          </a:prstGeom>
-          <a:noFill/>
-          <a:ln/>
-        </p:spPr>
-        <p:txBody>
-          <a:bodyPr wrap="square" lIns="0" tIns="0" rIns="0" bIns="0" rtlCol="0" anchor="ctr">
-            <a:normAutofit/>
-          </a:bodyPr>
-          <a:lstStyle/>
-          <a:p>
-            <a:pPr algn="l" indent="0" marL="0">
-              <a:buNone/>
-            </a:pPr>
-            <a:r>
-              <a:rPr lang="en-US" sz="1400" dirty="0">
-                <a:solidFill>
-                  <a:srgbClr val="5B6B7A"/>
-                </a:solidFill>
-                <a:latin typeface="Calibri" pitchFamily="34" charset="0"/>
-                <a:ea typeface="Calibri" pitchFamily="34" charset="-122"/>
-                <a:cs typeface="Calibri" pitchFamily="34" charset="-120"/>
-              </a:rPr>
-              <a:t>Chỉ vẽ phần đã triển khai đến Checkpoint 2.</a:t>
-            </a:r>
-            <a:endParaRPr lang="en-US" sz="1400" dirty="0"/>
-          </a:p>
-        </p:txBody>
-      </p:sp>
-      <p:sp>
-        <p:nvSpPr>
           <p:cNvPr id="5" name="Shape 3"/>
           <p:cNvSpPr/>
           <p:nvPr/>
         </p:nvSpPr>
         <p:spPr>
           <a:xfrm>
-            <a:off x="777240" y="1828800"/>
-            <a:ext cx="10634472" cy="4526280"/>
+            <a:off x="777240" y="1783080"/>
+            <a:ext cx="10634472" cy="3840480"/>
           </a:xfrm>
           <a:prstGeom prst="roundRect">
             <a:avLst>
@@ -1881,7 +1731,7 @@
         </p:nvSpPr>
         <p:spPr>
           <a:xfrm>
-            <a:off x="1033272" y="1956816"/>
+            <a:off x="1033272" y="1911096"/>
             <a:ext cx="10122408" cy="310896"/>
           </a:xfrm>
           <a:prstGeom prst="rect">
@@ -1908,7 +1758,7 @@
                 <a:ea typeface="Calibri" pitchFamily="34" charset="-122"/>
                 <a:cs typeface="Calibri" pitchFamily="34" charset="-120"/>
               </a:rPr>
-              <a:t>SƠ ĐỒ ARCHITECTURE — phần đã triển khai đến Checkpoint 2</a:t>
+              <a:t>SƠ ĐỒ ARCHITECTURE — phần đã triển khai</a:t>
             </a:r>
             <a:endParaRPr lang="en-US" sz="1600" dirty="0"/>
           </a:p>
@@ -1922,8 +1772,8 @@
         </p:nvSpPr>
         <p:spPr>
           <a:xfrm>
-            <a:off x="1033272" y="5376672"/>
-            <a:ext cx="10122408" cy="361320"/>
+            <a:off x="1033272" y="5074920"/>
+            <a:ext cx="10122408" cy="457200"/>
           </a:xfrm>
           <a:prstGeom prst="rect">
             <a:avLst/>
@@ -1949,7 +1799,7 @@
                 <a:ea typeface="Calibri" pitchFamily="34" charset="-122"/>
                 <a:cs typeface="Calibri" pitchFamily="34" charset="-120"/>
               </a:rPr>
-              <a:t>Trade-off chính: máy cá nhân 16 GB RAM nên nhóm chạy Spark local[*] và chuẩn hóa CSV trước (1 dòng = 1 record, 33 chunk) thay vì multiLine=true — nếu không, 1 task phải nạp nguyên file 8,59 GB vào RAM → OOM. Cột description (~8 GB) giữ nguyên ở raw, chỉ bỏ ở tầng metric.</a:t>
+              <a:t>Trade-off: copy nguyên bản (tốn 8,59 GB đĩa) để đổi lấy khả năng truy vết và xử lý lại từ raw.</a:t>
             </a:r>
             <a:endParaRPr lang="en-US" sz="1400" dirty="0"/>
           </a:p>
@@ -1963,12 +1813,12 @@
         </p:nvSpPr>
         <p:spPr>
           <a:xfrm>
-            <a:off x="1033272" y="2487168"/>
-            <a:ext cx="1488643" cy="1572768"/>
+            <a:off x="1033272" y="2542032"/>
+            <a:ext cx="3099816" cy="2240280"/>
           </a:xfrm>
           <a:prstGeom prst="roundRect">
             <a:avLst>
-              <a:gd name="adj" fmla="val 8000"/>
+              <a:gd name="adj" fmla="val 6000"/>
             </a:avLst>
           </a:prstGeom>
           <a:solidFill>
@@ -1991,14 +1841,14 @@
       </p:sp>
       <p:sp>
         <p:nvSpPr>
-          <p:cNvPr id="10" name="Badge 01"/>
-          <p:cNvSpPr/>
-          <p:nvPr/>
-        </p:nvSpPr>
-        <p:spPr>
-          <a:xfrm>
-            <a:off x="1161288" y="2670048"/>
-            <a:ext cx="402336" cy="329184"/>
+          <p:cNvPr id="10" name="Rounded Rectangle 9"/>
+          <p:cNvSpPr/>
+          <p:nvPr/>
+        </p:nvSpPr>
+        <p:spPr>
+          <a:xfrm>
+            <a:off x="1216152" y="2761488"/>
+            <a:ext cx="457200" cy="384048"/>
           </a:xfrm>
           <a:prstGeom prst="roundRect">
             <a:avLst>
@@ -2019,7 +1869,7 @@
           <a:p>
             <a:pPr algn="ctr"/>
             <a:r>
-              <a:rPr sz="1250" b="1">
+              <a:rPr sz="1300" b="1">
                 <a:solidFill>
                   <a:srgbClr val="FFFFFF"/>
                 </a:solidFill>
@@ -2038,8 +1888,8 @@
         </p:nvSpPr>
         <p:spPr>
           <a:xfrm>
-            <a:off x="1161288" y="3090672"/>
-            <a:ext cx="1250899" cy="172448"/>
+            <a:off x="1216152" y="3319272"/>
+            <a:ext cx="2734056" cy="246355"/>
           </a:xfrm>
           <a:prstGeom prst="rect">
             <a:avLst/>
@@ -2053,7 +1903,7 @@
           <a:lstStyle/>
           <a:p>
             <a:r>
-              <a:rPr sz="1050" b="1">
+              <a:rPr sz="1500" b="1">
                 <a:solidFill>
                   <a:srgbClr val="0B1F33"/>
                 </a:solidFill>
@@ -2072,8 +1922,8 @@
         </p:nvSpPr>
         <p:spPr>
           <a:xfrm>
-            <a:off x="1161288" y="3511296"/>
-            <a:ext cx="1250899" cy="279202"/>
+            <a:off x="1216152" y="3776472"/>
+            <a:ext cx="2734056" cy="361320"/>
           </a:xfrm>
           <a:prstGeom prst="rect">
             <a:avLst/>
@@ -2087,9 +1937,9 @@
           <a:lstStyle/>
           <a:p>
             <a:r>
-              <a:rPr sz="850" b="0">
-                <a:solidFill>
-                  <a:srgbClr val="8A9AA8"/>
+              <a:rPr sz="1100" b="0">
+                <a:solidFill>
+                  <a:srgbClr val="5B6B7A"/>
                 </a:solidFill>
                 <a:latin typeface="Calibri"/>
               </a:rPr>
@@ -2098,9 +1948,9 @@
           </a:p>
           <a:p>
             <a:r>
-              <a:rPr sz="850" b="0">
-                <a:solidFill>
-                  <a:srgbClr val="8A9AA8"/>
+              <a:rPr sz="1100" b="0">
+                <a:solidFill>
+                  <a:srgbClr val="5B6B7A"/>
                 </a:solidFill>
                 <a:latin typeface="Calibri"/>
               </a:rPr>
@@ -2117,8 +1967,8 @@
         </p:nvSpPr>
         <p:spPr>
           <a:xfrm>
-            <a:off x="2563063" y="3191256"/>
-            <a:ext cx="155448" cy="164592"/>
+            <a:off x="4215384" y="3552444"/>
+            <a:ext cx="246888" cy="219456"/>
           </a:xfrm>
           <a:prstGeom prst="rightArrow">
             <a:avLst/>
@@ -2147,12 +1997,12 @@
         </p:nvSpPr>
         <p:spPr>
           <a:xfrm>
-            <a:off x="2759659" y="2487168"/>
-            <a:ext cx="1488643" cy="1572768"/>
+            <a:off x="4544568" y="2542032"/>
+            <a:ext cx="3099816" cy="2240280"/>
           </a:xfrm>
           <a:prstGeom prst="roundRect">
             <a:avLst>
-              <a:gd name="adj" fmla="val 8000"/>
+              <a:gd name="adj" fmla="val 6000"/>
             </a:avLst>
           </a:prstGeom>
           <a:solidFill>
@@ -2175,14 +2025,14 @@
       </p:sp>
       <p:sp>
         <p:nvSpPr>
-          <p:cNvPr id="15" name="Badge 02"/>
-          <p:cNvSpPr/>
-          <p:nvPr/>
-        </p:nvSpPr>
-        <p:spPr>
-          <a:xfrm>
-            <a:off x="2887675" y="2670048"/>
-            <a:ext cx="402336" cy="329184"/>
+          <p:cNvPr id="15" name="Rounded Rectangle 14"/>
+          <p:cNvSpPr/>
+          <p:nvPr/>
+        </p:nvSpPr>
+        <p:spPr>
+          <a:xfrm>
+            <a:off x="4727448" y="2761488"/>
+            <a:ext cx="457200" cy="384048"/>
           </a:xfrm>
           <a:prstGeom prst="roundRect">
             <a:avLst>
@@ -2203,7 +2053,7 @@
           <a:p>
             <a:pPr algn="ctr"/>
             <a:r>
-              <a:rPr sz="1250" b="1">
+              <a:rPr sz="1300" b="1">
                 <a:solidFill>
                   <a:srgbClr val="FFFFFF"/>
                 </a:solidFill>
@@ -2222,8 +2072,8 @@
         </p:nvSpPr>
         <p:spPr>
           <a:xfrm>
-            <a:off x="2887675" y="3090672"/>
-            <a:ext cx="1250899" cy="172448"/>
+            <a:off x="4727448" y="3319272"/>
+            <a:ext cx="2734056" cy="246355"/>
           </a:xfrm>
           <a:prstGeom prst="rect">
             <a:avLst/>
@@ -2237,7 +2087,7 @@
           <a:lstStyle/>
           <a:p>
             <a:r>
-              <a:rPr sz="1050" b="1">
+              <a:rPr sz="1500" b="1">
                 <a:solidFill>
                   <a:srgbClr val="0B1F33"/>
                 </a:solidFill>
@@ -2256,8 +2106,8 @@
         </p:nvSpPr>
         <p:spPr>
           <a:xfrm>
-            <a:off x="2887675" y="3511296"/>
-            <a:ext cx="1250899" cy="279202"/>
+            <a:off x="4727448" y="3776472"/>
+            <a:ext cx="2734056" cy="361320"/>
           </a:xfrm>
           <a:prstGeom prst="rect">
             <a:avLst/>
@@ -2271,9 +2121,9 @@
           <a:lstStyle/>
           <a:p>
             <a:r>
-              <a:rPr sz="850" b="0">
-                <a:solidFill>
-                  <a:srgbClr val="8A9AA8"/>
+              <a:rPr sz="1100" b="0">
+                <a:solidFill>
+                  <a:srgbClr val="5B6B7A"/>
                 </a:solidFill>
                 <a:latin typeface="Calibri"/>
               </a:rPr>
@@ -2282,9 +2132,9 @@
           </a:p>
           <a:p>
             <a:r>
-              <a:rPr sz="850" b="0">
-                <a:solidFill>
-                  <a:srgbClr val="8A9AA8"/>
+              <a:rPr sz="1100" b="0">
+                <a:solidFill>
+                  <a:srgbClr val="5B6B7A"/>
                 </a:solidFill>
                 <a:latin typeface="Calibri"/>
               </a:rPr>
@@ -2301,8 +2151,8 @@
         </p:nvSpPr>
         <p:spPr>
           <a:xfrm>
-            <a:off x="4289450" y="3191256"/>
-            <a:ext cx="155448" cy="164592"/>
+            <a:off x="7726680" y="3552444"/>
+            <a:ext cx="246888" cy="219456"/>
           </a:xfrm>
           <a:prstGeom prst="rightArrow">
             <a:avLst/>
@@ -2331,12 +2181,12 @@
         </p:nvSpPr>
         <p:spPr>
           <a:xfrm>
-            <a:off x="4486046" y="2487168"/>
-            <a:ext cx="1488643" cy="1572768"/>
+            <a:off x="8055864" y="2542032"/>
+            <a:ext cx="3099816" cy="2240280"/>
           </a:xfrm>
           <a:prstGeom prst="roundRect">
             <a:avLst>
-              <a:gd name="adj" fmla="val 8000"/>
+              <a:gd name="adj" fmla="val 6000"/>
             </a:avLst>
           </a:prstGeom>
           <a:solidFill>
@@ -2359,14 +2209,14 @@
       </p:sp>
       <p:sp>
         <p:nvSpPr>
-          <p:cNvPr id="20" name="Badge 03"/>
-          <p:cNvSpPr/>
-          <p:nvPr/>
-        </p:nvSpPr>
-        <p:spPr>
-          <a:xfrm>
-            <a:off x="4614062" y="2670048"/>
-            <a:ext cx="402336" cy="329184"/>
+          <p:cNvPr id="20" name="Rounded Rectangle 19"/>
+          <p:cNvSpPr/>
+          <p:nvPr/>
+        </p:nvSpPr>
+        <p:spPr>
+          <a:xfrm>
+            <a:off x="8238744" y="2761488"/>
+            <a:ext cx="457200" cy="384048"/>
           </a:xfrm>
           <a:prstGeom prst="roundRect">
             <a:avLst>
@@ -2387,7 +2237,7 @@
           <a:p>
             <a:pPr algn="ctr"/>
             <a:r>
-              <a:rPr sz="1250" b="1">
+              <a:rPr sz="1300" b="1">
                 <a:solidFill>
                   <a:srgbClr val="FFFFFF"/>
                 </a:solidFill>
@@ -2406,8 +2256,8 @@
         </p:nvSpPr>
         <p:spPr>
           <a:xfrm>
-            <a:off x="4614062" y="3090672"/>
-            <a:ext cx="1250899" cy="172448"/>
+            <a:off x="8238744" y="3319272"/>
+            <a:ext cx="2734056" cy="246355"/>
           </a:xfrm>
           <a:prstGeom prst="rect">
             <a:avLst/>
@@ -2421,7 +2271,7 @@
           <a:lstStyle/>
           <a:p>
             <a:r>
-              <a:rPr sz="1050" b="1">
+              <a:rPr sz="1500" b="1">
                 <a:solidFill>
                   <a:srgbClr val="0B1F33"/>
                 </a:solidFill>
@@ -2440,8 +2290,8 @@
         </p:nvSpPr>
         <p:spPr>
           <a:xfrm>
-            <a:off x="4614062" y="3511296"/>
-            <a:ext cx="1250899" cy="279202"/>
+            <a:off x="8238744" y="3776472"/>
+            <a:ext cx="2734056" cy="361320"/>
           </a:xfrm>
           <a:prstGeom prst="rect">
             <a:avLst/>
@@ -2455,9 +2305,9 @@
           <a:lstStyle/>
           <a:p>
             <a:r>
-              <a:rPr sz="850" b="0">
-                <a:solidFill>
-                  <a:srgbClr val="8A9AA8"/>
+              <a:rPr sz="1100" b="0">
+                <a:solidFill>
+                  <a:srgbClr val="5B6B7A"/>
                 </a:solidFill>
                 <a:latin typeface="Calibri"/>
               </a:rPr>
@@ -2466,716 +2316,14 @@
           </a:p>
           <a:p>
             <a:r>
-              <a:rPr sz="850" b="0">
-                <a:solidFill>
-                  <a:srgbClr val="8A9AA8"/>
+              <a:rPr sz="1100" b="0">
+                <a:solidFill>
+                  <a:srgbClr val="5B6B7A"/>
                 </a:solidFill>
                 <a:latin typeface="Calibri"/>
               </a:rPr>
               <a:t>+ manifest.json</a:t>
             </a:r>
-          </a:p>
-        </p:txBody>
-      </p:sp>
-      <p:sp>
-        <p:nvSpPr>
-          <p:cNvPr id="23" name="Right Arrow 22"/>
-          <p:cNvSpPr/>
-          <p:nvPr/>
-        </p:nvSpPr>
-        <p:spPr>
-          <a:xfrm>
-            <a:off x="6015838" y="3191256"/>
-            <a:ext cx="155448" cy="164592"/>
-          </a:xfrm>
-          <a:prstGeom prst="rightArrow">
-            <a:avLst/>
-          </a:prstGeom>
-          <a:solidFill>
-            <a:srgbClr val="8A9AA8"/>
-          </a:solidFill>
-          <a:ln>
-            <a:noFill/>
-          </a:ln>
-          <a:effectLst/>
-        </p:spPr>
-        <p:txBody>
-          <a:bodyPr rtlCol="0" anchor="ctr" wrap="square" lIns="0" rIns="0" tIns="0" bIns="0"/>
-          <a:lstStyle/>
-          <a:p>
-            <a:pPr algn="ctr"/>
-          </a:p>
-        </p:txBody>
-      </p:sp>
-      <p:sp>
-        <p:nvSpPr>
-          <p:cNvPr id="24" name="Rounded Rectangle 23"/>
-          <p:cNvSpPr/>
-          <p:nvPr/>
-        </p:nvSpPr>
-        <p:spPr>
-          <a:xfrm>
-            <a:off x="6212434" y="2487168"/>
-            <a:ext cx="1488643" cy="1572768"/>
-          </a:xfrm>
-          <a:prstGeom prst="roundRect">
-            <a:avLst>
-              <a:gd name="adj" fmla="val 8000"/>
-            </a:avLst>
-          </a:prstGeom>
-          <a:solidFill>
-            <a:srgbClr val="F4F6F8"/>
-          </a:solidFill>
-          <a:ln w="12700">
-            <a:solidFill>
-              <a:srgbClr val="8A9AA8"/>
-            </a:solidFill>
-          </a:ln>
-          <a:effectLst/>
-        </p:spPr>
-        <p:txBody>
-          <a:bodyPr rtlCol="0" anchor="ctr" wrap="square" lIns="0" rIns="0" tIns="0" bIns="0"/>
-          <a:lstStyle/>
-          <a:p>
-            <a:pPr algn="ctr"/>
-          </a:p>
-        </p:txBody>
-      </p:sp>
-      <p:sp>
-        <p:nvSpPr>
-          <p:cNvPr id="25" name="Badge 04"/>
-          <p:cNvSpPr/>
-          <p:nvPr/>
-        </p:nvSpPr>
-        <p:spPr>
-          <a:xfrm>
-            <a:off x="6340450" y="2670048"/>
-            <a:ext cx="402336" cy="329184"/>
-          </a:xfrm>
-          <a:prstGeom prst="roundRect">
-            <a:avLst>
-              <a:gd name="adj" fmla="val 25000"/>
-            </a:avLst>
-          </a:prstGeom>
-          <a:solidFill>
-            <a:srgbClr val="8A9AA8"/>
-          </a:solidFill>
-          <a:ln>
-            <a:noFill/>
-          </a:ln>
-          <a:effectLst/>
-        </p:spPr>
-        <p:txBody>
-          <a:bodyPr rtlCol="0" anchor="ctr" wrap="square" lIns="0" rIns="0" tIns="0" bIns="0"/>
-          <a:lstStyle/>
-          <a:p>
-            <a:pPr algn="ctr"/>
-            <a:r>
-              <a:rPr sz="1250" b="1">
-                <a:solidFill>
-                  <a:srgbClr val="FFFFFF"/>
-                </a:solidFill>
-                <a:latin typeface="Calibri"/>
-              </a:rPr>
-              <a:t>04</a:t>
-            </a:r>
-          </a:p>
-        </p:txBody>
-      </p:sp>
-      <p:sp>
-        <p:nvSpPr>
-          <p:cNvPr id="26" name="TextBox 25"/>
-          <p:cNvSpPr txBox="1"/>
-          <p:nvPr/>
-        </p:nvSpPr>
-        <p:spPr>
-          <a:xfrm>
-            <a:off x="6340450" y="3090672"/>
-            <a:ext cx="1250899" cy="172448"/>
-          </a:xfrm>
-          <a:prstGeom prst="rect">
-            <a:avLst/>
-          </a:prstGeom>
-          <a:noFill/>
-        </p:spPr>
-        <p:txBody>
-          <a:bodyPr wrap="square" lIns="0" rIns="0" tIns="0" bIns="0" anchor="t">
-            <a:spAutoFit/>
-          </a:bodyPr>
-          <a:lstStyle/>
-          <a:p>
-            <a:r>
-              <a:rPr sz="1050" b="1">
-                <a:solidFill>
-                  <a:srgbClr val="0B1F33"/>
-                </a:solidFill>
-                <a:latin typeface="Calibri"/>
-              </a:rPr>
-              <a:t>split_csv.py</a:t>
-            </a:r>
-          </a:p>
-        </p:txBody>
-      </p:sp>
-      <p:sp>
-        <p:nvSpPr>
-          <p:cNvPr id="27" name="TextBox 26"/>
-          <p:cNvSpPr txBox="1"/>
-          <p:nvPr/>
-        </p:nvSpPr>
-        <p:spPr>
-          <a:xfrm>
-            <a:off x="6340450" y="3511296"/>
-            <a:ext cx="1250899" cy="279202"/>
-          </a:xfrm>
-          <a:prstGeom prst="rect">
-            <a:avLst/>
-          </a:prstGeom>
-          <a:noFill/>
-        </p:spPr>
-        <p:txBody>
-          <a:bodyPr wrap="square" lIns="0" rIns="0" tIns="0" bIns="0" anchor="t">
-            <a:spAutoFit/>
-          </a:bodyPr>
-          <a:lstStyle/>
-          <a:p>
-            <a:r>
-              <a:rPr sz="850" b="0">
-                <a:solidFill>
-                  <a:srgbClr val="8A9AA8"/>
-                </a:solidFill>
-                <a:latin typeface="Calibri"/>
-              </a:rPr>
-              <a:t>1 dòng = 1 record</a:t>
-            </a:r>
-          </a:p>
-          <a:p>
-            <a:r>
-              <a:rPr sz="850" b="0">
-                <a:solidFill>
-                  <a:srgbClr val="8A9AA8"/>
-                </a:solidFill>
-                <a:latin typeface="Calibri"/>
-              </a:rPr>
-              <a:t>→ 33 chunk CSV</a:t>
-            </a:r>
-          </a:p>
-        </p:txBody>
-      </p:sp>
-      <p:sp>
-        <p:nvSpPr>
-          <p:cNvPr id="28" name="Right Arrow 27"/>
-          <p:cNvSpPr/>
-          <p:nvPr/>
-        </p:nvSpPr>
-        <p:spPr>
-          <a:xfrm>
-            <a:off x="7742225" y="3191256"/>
-            <a:ext cx="155448" cy="164592"/>
-          </a:xfrm>
-          <a:prstGeom prst="rightArrow">
-            <a:avLst/>
-          </a:prstGeom>
-          <a:solidFill>
-            <a:srgbClr val="8A9AA8"/>
-          </a:solidFill>
-          <a:ln>
-            <a:noFill/>
-          </a:ln>
-          <a:effectLst/>
-        </p:spPr>
-        <p:txBody>
-          <a:bodyPr rtlCol="0" anchor="ctr" wrap="square" lIns="0" rIns="0" tIns="0" bIns="0"/>
-          <a:lstStyle/>
-          <a:p>
-            <a:pPr algn="ctr"/>
-          </a:p>
-        </p:txBody>
-      </p:sp>
-      <p:sp>
-        <p:nvSpPr>
-          <p:cNvPr id="29" name="Rounded Rectangle 28"/>
-          <p:cNvSpPr/>
-          <p:nvPr/>
-        </p:nvSpPr>
-        <p:spPr>
-          <a:xfrm>
-            <a:off x="7938821" y="2487168"/>
-            <a:ext cx="1488643" cy="1572768"/>
-          </a:xfrm>
-          <a:prstGeom prst="roundRect">
-            <a:avLst>
-              <a:gd name="adj" fmla="val 8000"/>
-            </a:avLst>
-          </a:prstGeom>
-          <a:solidFill>
-            <a:srgbClr val="F4F6F8"/>
-          </a:solidFill>
-          <a:ln w="12700">
-            <a:solidFill>
-              <a:srgbClr val="8A9AA8"/>
-            </a:solidFill>
-          </a:ln>
-          <a:effectLst/>
-        </p:spPr>
-        <p:txBody>
-          <a:bodyPr rtlCol="0" anchor="ctr" wrap="square" lIns="0" rIns="0" tIns="0" bIns="0"/>
-          <a:lstStyle/>
-          <a:p>
-            <a:pPr algn="ctr"/>
-          </a:p>
-        </p:txBody>
-      </p:sp>
-      <p:sp>
-        <p:nvSpPr>
-          <p:cNvPr id="30" name="Badge 05"/>
-          <p:cNvSpPr/>
-          <p:nvPr/>
-        </p:nvSpPr>
-        <p:spPr>
-          <a:xfrm>
-            <a:off x="8066837" y="2670048"/>
-            <a:ext cx="402336" cy="329184"/>
-          </a:xfrm>
-          <a:prstGeom prst="roundRect">
-            <a:avLst>
-              <a:gd name="adj" fmla="val 25000"/>
-            </a:avLst>
-          </a:prstGeom>
-          <a:solidFill>
-            <a:srgbClr val="8A9AA8"/>
-          </a:solidFill>
-          <a:ln>
-            <a:noFill/>
-          </a:ln>
-          <a:effectLst/>
-        </p:spPr>
-        <p:txBody>
-          <a:bodyPr rtlCol="0" anchor="ctr" wrap="square" lIns="0" rIns="0" tIns="0" bIns="0"/>
-          <a:lstStyle/>
-          <a:p>
-            <a:pPr algn="ctr"/>
-            <a:r>
-              <a:rPr sz="1250" b="1">
-                <a:solidFill>
-                  <a:srgbClr val="FFFFFF"/>
-                </a:solidFill>
-                <a:latin typeface="Calibri"/>
-              </a:rPr>
-              <a:t>05</a:t>
-            </a:r>
-          </a:p>
-        </p:txBody>
-      </p:sp>
-      <p:sp>
-        <p:nvSpPr>
-          <p:cNvPr id="31" name="TextBox 30"/>
-          <p:cNvSpPr txBox="1"/>
-          <p:nvPr/>
-        </p:nvSpPr>
-        <p:spPr>
-          <a:xfrm>
-            <a:off x="8066837" y="3090672"/>
-            <a:ext cx="1250899" cy="172448"/>
-          </a:xfrm>
-          <a:prstGeom prst="rect">
-            <a:avLst/>
-          </a:prstGeom>
-          <a:noFill/>
-        </p:spPr>
-        <p:txBody>
-          <a:bodyPr wrap="square" lIns="0" rIns="0" tIns="0" bIns="0" anchor="t">
-            <a:spAutoFit/>
-          </a:bodyPr>
-          <a:lstStyle/>
-          <a:p>
-            <a:r>
-              <a:rPr sz="1050" b="1">
-                <a:solidFill>
-                  <a:srgbClr val="0B1F33"/>
-                </a:solidFill>
-                <a:latin typeface="Calibri"/>
-              </a:rPr>
-              <a:t>Spark 3.5.1</a:t>
-            </a:r>
-          </a:p>
-        </p:txBody>
-      </p:sp>
-      <p:sp>
-        <p:nvSpPr>
-          <p:cNvPr id="32" name="TextBox 31"/>
-          <p:cNvSpPr txBox="1"/>
-          <p:nvPr/>
-        </p:nvSpPr>
-        <p:spPr>
-          <a:xfrm>
-            <a:off x="8066837" y="3511296"/>
-            <a:ext cx="1250899" cy="279202"/>
-          </a:xfrm>
-          <a:prstGeom prst="rect">
-            <a:avLst/>
-          </a:prstGeom>
-          <a:noFill/>
-        </p:spPr>
-        <p:txBody>
-          <a:bodyPr wrap="square" lIns="0" rIns="0" tIns="0" bIns="0" anchor="t">
-            <a:spAutoFit/>
-          </a:bodyPr>
-          <a:lstStyle/>
-          <a:p>
-            <a:r>
-              <a:rPr sz="850" b="0">
-                <a:solidFill>
-                  <a:srgbClr val="8A9AA8"/>
-                </a:solidFill>
-                <a:latin typeface="Calibri"/>
-              </a:rPr>
-              <a:t>local[*] → Parquet</a:t>
-            </a:r>
-          </a:p>
-          <a:p>
-            <a:r>
-              <a:rPr sz="850" b="0">
-                <a:solidFill>
-                  <a:srgbClr val="8A9AA8"/>
-                </a:solidFill>
-                <a:latin typeface="Calibri"/>
-              </a:rPr>
-              <a:t>341 MB, partition</a:t>
-            </a:r>
-          </a:p>
-        </p:txBody>
-      </p:sp>
-      <p:sp>
-        <p:nvSpPr>
-          <p:cNvPr id="33" name="Right Arrow 32"/>
-          <p:cNvSpPr/>
-          <p:nvPr/>
-        </p:nvSpPr>
-        <p:spPr>
-          <a:xfrm>
-            <a:off x="9468612" y="3191256"/>
-            <a:ext cx="155448" cy="164592"/>
-          </a:xfrm>
-          <a:prstGeom prst="rightArrow">
-            <a:avLst/>
-          </a:prstGeom>
-          <a:solidFill>
-            <a:srgbClr val="8A9AA8"/>
-          </a:solidFill>
-          <a:ln>
-            <a:noFill/>
-          </a:ln>
-          <a:effectLst/>
-        </p:spPr>
-        <p:txBody>
-          <a:bodyPr rtlCol="0" anchor="ctr" wrap="square" lIns="0" rIns="0" tIns="0" bIns="0"/>
-          <a:lstStyle/>
-          <a:p>
-            <a:pPr algn="ctr"/>
-          </a:p>
-        </p:txBody>
-      </p:sp>
-      <p:sp>
-        <p:nvSpPr>
-          <p:cNvPr id="34" name="Rounded Rectangle 33"/>
-          <p:cNvSpPr/>
-          <p:nvPr/>
-        </p:nvSpPr>
-        <p:spPr>
-          <a:xfrm>
-            <a:off x="9665208" y="2487168"/>
-            <a:ext cx="1488643" cy="1572768"/>
-          </a:xfrm>
-          <a:prstGeom prst="roundRect">
-            <a:avLst>
-              <a:gd name="adj" fmla="val 8000"/>
-            </a:avLst>
-          </a:prstGeom>
-          <a:solidFill>
-            <a:srgbClr val="F4F6F8"/>
-          </a:solidFill>
-          <a:ln w="12700">
-            <a:solidFill>
-              <a:srgbClr val="8A9AA8"/>
-            </a:solidFill>
-          </a:ln>
-          <a:effectLst/>
-        </p:spPr>
-        <p:txBody>
-          <a:bodyPr rtlCol="0" anchor="ctr" wrap="square" lIns="0" rIns="0" tIns="0" bIns="0"/>
-          <a:lstStyle/>
-          <a:p>
-            <a:pPr algn="ctr"/>
-          </a:p>
-        </p:txBody>
-      </p:sp>
-      <p:sp>
-        <p:nvSpPr>
-          <p:cNvPr id="35" name="Badge 06"/>
-          <p:cNvSpPr/>
-          <p:nvPr/>
-        </p:nvSpPr>
-        <p:spPr>
-          <a:xfrm>
-            <a:off x="9793224" y="2670048"/>
-            <a:ext cx="402336" cy="329184"/>
-          </a:xfrm>
-          <a:prstGeom prst="roundRect">
-            <a:avLst>
-              <a:gd name="adj" fmla="val 25000"/>
-            </a:avLst>
-          </a:prstGeom>
-          <a:solidFill>
-            <a:srgbClr val="8A9AA8"/>
-          </a:solidFill>
-          <a:ln>
-            <a:noFill/>
-          </a:ln>
-          <a:effectLst/>
-        </p:spPr>
-        <p:txBody>
-          <a:bodyPr rtlCol="0" anchor="ctr" wrap="square" lIns="0" rIns="0" tIns="0" bIns="0"/>
-          <a:lstStyle/>
-          <a:p>
-            <a:pPr algn="ctr"/>
-            <a:r>
-              <a:rPr sz="1250" b="1">
-                <a:solidFill>
-                  <a:srgbClr val="FFFFFF"/>
-                </a:solidFill>
-                <a:latin typeface="Calibri"/>
-              </a:rPr>
-              <a:t>06</a:t>
-            </a:r>
-          </a:p>
-        </p:txBody>
-      </p:sp>
-      <p:sp>
-        <p:nvSpPr>
-          <p:cNvPr id="36" name="TextBox 35"/>
-          <p:cNvSpPr txBox="1"/>
-          <p:nvPr/>
-        </p:nvSpPr>
-        <p:spPr>
-          <a:xfrm>
-            <a:off x="9793224" y="3090672"/>
-            <a:ext cx="1250899" cy="172448"/>
-          </a:xfrm>
-          <a:prstGeom prst="rect">
-            <a:avLst/>
-          </a:prstGeom>
-          <a:noFill/>
-        </p:spPr>
-        <p:txBody>
-          <a:bodyPr wrap="square" lIns="0" rIns="0" tIns="0" bIns="0" anchor="t">
-            <a:spAutoFit/>
-          </a:bodyPr>
-          <a:lstStyle/>
-          <a:p>
-            <a:r>
-              <a:rPr sz="1050" b="1">
-                <a:solidFill>
-                  <a:srgbClr val="0B1F33"/>
-                </a:solidFill>
-                <a:latin typeface="Calibri"/>
-              </a:rPr>
-              <a:t>DuckDB/Streamlit</a:t>
-            </a:r>
-          </a:p>
-        </p:txBody>
-      </p:sp>
-      <p:sp>
-        <p:nvSpPr>
-          <p:cNvPr id="37" name="TextBox 36"/>
-          <p:cNvSpPr txBox="1"/>
-          <p:nvPr/>
-        </p:nvSpPr>
-        <p:spPr>
-          <a:xfrm>
-            <a:off x="9793224" y="3511296"/>
-            <a:ext cx="1250899" cy="279202"/>
-          </a:xfrm>
-          <a:prstGeom prst="rect">
-            <a:avLst/>
-          </a:prstGeom>
-          <a:noFill/>
-        </p:spPr>
-        <p:txBody>
-          <a:bodyPr wrap="square" lIns="0" rIns="0" tIns="0" bIns="0" anchor="t">
-            <a:spAutoFit/>
-          </a:bodyPr>
-          <a:lstStyle/>
-          <a:p>
-            <a:r>
-              <a:rPr sz="850" b="0">
-                <a:solidFill>
-                  <a:srgbClr val="8A9AA8"/>
-                </a:solidFill>
-                <a:latin typeface="Calibri"/>
-              </a:rPr>
-              <a:t>dashboard tương tác</a:t>
-            </a:r>
-          </a:p>
-          <a:p>
-            <a:r>
-              <a:rPr sz="850" b="0">
-                <a:solidFill>
-                  <a:srgbClr val="8A9AA8"/>
-                </a:solidFill>
-                <a:latin typeface="Calibri"/>
-              </a:rPr>
-              <a:t>(P3 – làm thêm)</a:t>
-            </a:r>
-          </a:p>
-        </p:txBody>
-      </p:sp>
-      <p:sp>
-        <p:nvSpPr>
-          <p:cNvPr id="38" name="TextBox 37"/>
-          <p:cNvSpPr txBox="1"/>
-          <p:nvPr/>
-        </p:nvSpPr>
-        <p:spPr>
-          <a:xfrm>
-            <a:off x="1033272" y="4261104"/>
-            <a:ext cx="10122408" cy="172448"/>
-          </a:xfrm>
-          <a:prstGeom prst="rect">
-            <a:avLst/>
-          </a:prstGeom>
-          <a:noFill/>
-        </p:spPr>
-        <p:txBody>
-          <a:bodyPr wrap="square" lIns="0" rIns="0" tIns="0" bIns="0" anchor="t">
-            <a:spAutoFit/>
-          </a:bodyPr>
-          <a:lstStyle/>
-          <a:p>
-            <a:r>
-              <a:rPr sz="1050" b="0">
-                <a:solidFill>
-                  <a:srgbClr val="5B6B7A"/>
-                </a:solidFill>
-                <a:latin typeface="Calibri"/>
-              </a:rPr>
-              <a:t>Technology:  Python 3.12 · JDK 17 · PySpark 3.5.1 · DuckDB · Streamlit · Parquet</a:t>
-            </a:r>
-          </a:p>
-        </p:txBody>
-      </p:sp>
-      <p:sp>
-        <p:nvSpPr>
-          <p:cNvPr id="39" name="Band CK"/>
-          <p:cNvSpPr/>
-          <p:nvPr/>
-        </p:nvSpPr>
-        <p:spPr>
-          <a:xfrm>
-            <a:off x="1033272" y="4626864"/>
-            <a:ext cx="4956048" cy="420624"/>
-          </a:xfrm>
-          <a:prstGeom prst="roundRect">
-            <a:avLst>
-              <a:gd name="adj" fmla="val 14000"/>
-            </a:avLst>
-          </a:prstGeom>
-          <a:solidFill>
-            <a:srgbClr val="EFF6FF"/>
-          </a:solidFill>
-          <a:ln w="11430">
-            <a:solidFill>
-              <a:srgbClr val="1D4ED8"/>
-            </a:solidFill>
-          </a:ln>
-          <a:effectLst/>
-        </p:spPr>
-        <p:txBody>
-          <a:bodyPr rtlCol="0" anchor="ctr" wrap="square" lIns="0" rIns="0" tIns="0" bIns="0"/>
-          <a:lstStyle/>
-          <a:p>
-            <a:pPr algn="ctr"/>
-            <a:r>
-              <a:rPr sz="1050" b="0">
-                <a:solidFill>
-                  <a:srgbClr val="1D4ED8"/>
-                </a:solidFill>
-                <a:latin typeface="Calibri"/>
-              </a:rPr>
-              <a:t>TRONG CHECKPOINT 2 — 01 → 02 → 03, có evidence chạy thật</a:t>
-            </a:r>
-          </a:p>
-        </p:txBody>
-      </p:sp>
-      <p:sp>
-        <p:nvSpPr>
-          <p:cNvPr id="40" name="Band P3"/>
-          <p:cNvSpPr/>
-          <p:nvPr/>
-        </p:nvSpPr>
-        <p:spPr>
-          <a:xfrm>
-            <a:off x="6016752" y="4626864"/>
-            <a:ext cx="4882896" cy="420624"/>
-          </a:xfrm>
-          <a:prstGeom prst="roundRect">
-            <a:avLst>
-              <a:gd name="adj" fmla="val 14000"/>
-            </a:avLst>
-          </a:prstGeom>
-          <a:solidFill>
-            <a:srgbClr val="F4F6F8"/>
-          </a:solidFill>
-          <a:ln w="11430">
-            <a:solidFill>
-              <a:srgbClr val="8A9AA8"/>
-            </a:solidFill>
-          </a:ln>
-          <a:effectLst/>
-        </p:spPr>
-        <p:txBody>
-          <a:bodyPr rtlCol="0" anchor="ctr" wrap="square" lIns="0" rIns="0" tIns="0" bIns="0"/>
-          <a:lstStyle/>
-          <a:p>
-            <a:pPr algn="ctr"/>
-            <a:r>
-              <a:rPr sz="1050" b="0">
-                <a:solidFill>
-                  <a:srgbClr val="5B6B7A"/>
-                </a:solidFill>
-                <a:latin typeface="Calibri"/>
-              </a:rPr>
-              <a:t>BUỔI 7–8 (P3) — 04 → 05 → 06, làm thêm ngoài yêu cầu</a:t>
-            </a:r>
-          </a:p>
-        </p:txBody>
-      </p:sp>
-      <p:sp>
-        <p:nvSpPr>
-          <p:cNvPr id="41" name="Rectangle 40"/>
-          <p:cNvSpPr/>
-          <p:nvPr/>
-        </p:nvSpPr>
-        <p:spPr>
-          <a:xfrm>
-            <a:off x="1033272" y="5248656"/>
-            <a:ext cx="9866376" cy="10973"/>
-          </a:xfrm>
-          <a:prstGeom prst="rect">
-            <a:avLst/>
-          </a:prstGeom>
-          <a:solidFill>
-            <a:srgbClr val="DBE3EA"/>
-          </a:solidFill>
-          <a:ln>
-            <a:noFill/>
-          </a:ln>
-          <a:effectLst/>
-        </p:spPr>
-        <p:txBody>
-          <a:bodyPr rtlCol="0" anchor="ctr" wrap="square" lIns="0" rIns="0" tIns="0" bIns="0"/>
-          <a:lstStyle/>
-          <a:p>
-            <a:pPr algn="ctr"/>
           </a:p>
         </p:txBody>
       </p:sp>
@@ -3288,55 +2436,14 @@
       </p:sp>
       <p:sp>
         <p:nvSpPr>
-          <p:cNvPr id="4" name="Text 2"/>
-          <p:cNvSpPr/>
-          <p:nvPr/>
-        </p:nvSpPr>
-        <p:spPr>
-          <a:xfrm>
-            <a:off x="594360" y="1261872"/>
-            <a:ext cx="10972800" cy="310896"/>
-          </a:xfrm>
-          <a:prstGeom prst="rect">
-            <a:avLst/>
-          </a:prstGeom>
-          <a:noFill/>
-          <a:ln/>
-        </p:spPr>
-        <p:txBody>
-          <a:bodyPr wrap="square" lIns="0" tIns="0" rIns="0" bIns="0" rtlCol="0" anchor="ctr">
-            <a:normAutofit/>
-          </a:bodyPr>
-          <a:lstStyle/>
-          <a:p>
-            <a:pPr algn="l" indent="0" marL="0">
-              <a:buNone/>
-            </a:pPr>
-            <a:r>
-              <a:rPr lang="en-US" sz="1400" dirty="0">
-                <a:solidFill>
-                  <a:srgbClr val="5B6B7A"/>
-                </a:solidFill>
-                <a:latin typeface="Calibri" pitchFamily="34" charset="0"/>
-                <a:ea typeface="Calibri" pitchFamily="34" charset="-122"/>
-                <a:cs typeface="Calibri" pitchFamily="34" charset="-120"/>
-              </a:rPr>
-              <a:t>Chứng minh có thể tái tạo và chạy Spark.</a:t>
-            </a:r>
-            <a:endParaRPr lang="en-US" sz="1400" dirty="0"/>
-          </a:p>
-        </p:txBody>
-      </p:sp>
-      <p:sp>
-        <p:nvSpPr>
           <p:cNvPr id="5" name="Shape 3"/>
           <p:cNvSpPr/>
           <p:nvPr/>
         </p:nvSpPr>
         <p:spPr>
           <a:xfrm>
-            <a:off x="777240" y="1828800"/>
-            <a:ext cx="5074920" cy="4526280"/>
+            <a:off x="777240" y="1783080"/>
+            <a:ext cx="5074920" cy="4572000"/>
           </a:xfrm>
           <a:prstGeom prst="roundRect">
             <a:avLst>
@@ -3362,7 +2469,7 @@
         </p:nvSpPr>
         <p:spPr>
           <a:xfrm>
-            <a:off x="1033272" y="1956816"/>
+            <a:off x="1033272" y="1911096"/>
             <a:ext cx="4562856" cy="310896"/>
           </a:xfrm>
           <a:prstGeom prst="rect">
@@ -3403,8 +2510,8 @@
         </p:nvSpPr>
         <p:spPr>
           <a:xfrm>
-            <a:off x="1033272" y="2582906"/>
-            <a:ext cx="4562856" cy="3402117"/>
+            <a:off x="1033272" y="2331720"/>
+            <a:ext cx="4562856" cy="1323045"/>
           </a:xfrm>
           <a:prstGeom prst="rect">
             <a:avLst/>
@@ -3463,7 +2570,7 @@
                 <a:ea typeface="Calibri" pitchFamily="34" charset="-122"/>
                 <a:cs typeface="Calibri" pitchFamily="34" charset="-120"/>
               </a:rPr>
-              <a:t>=== env_check 2026-10-21T17:11:56+00:00 ===</a:t>
+              <a:t>Python   : 3.12.10</a:t>
             </a:r>
           </a:p>
           <a:p>
@@ -3479,7 +2586,7 @@
                 <a:ea typeface="Calibri" pitchFamily="34" charset="-122"/>
                 <a:cs typeface="Calibri" pitchFamily="34" charset="-120"/>
               </a:rPr>
-              <a:t>Python   : 3.12.10  (E:\bigdata-project)</a:t>
+              <a:t>Java     : 17.0.20.1</a:t>
             </a:r>
           </a:p>
           <a:p>
@@ -3495,7 +2602,7 @@
                 <a:ea typeface="Calibri" pitchFamily="34" charset="-122"/>
                 <a:cs typeface="Calibri" pitchFamily="34" charset="-120"/>
               </a:rPr>
-              <a:t>JAVA_HOME: D:\Code\SDK\jdk\jdk-17.0.20.1+1</a:t>
+              <a:t>Spark    : 3.5.1</a:t>
             </a:r>
           </a:p>
           <a:p>
@@ -3511,39 +2618,7 @@
                 <a:ea typeface="Calibri" pitchFamily="34" charset="-122"/>
                 <a:cs typeface="Calibri" pitchFamily="34" charset="-120"/>
               </a:rPr>
-              <a:t>Java     : openjdk version "17.0.20.1"</a:t>
-            </a:r>
-          </a:p>
-          <a:p>
-            <a:pPr algn="l" indent="0" marL="0">
-              <a:buNone/>
-            </a:pPr>
-            <a:r>
-              <a:rPr lang="en-US" sz="1200" dirty="0" b="0">
-                <a:solidFill>
-                  <a:srgbClr val="5B6B7A"/>
-                </a:solidFill>
-                <a:latin typeface="Consolas" pitchFamily="34" charset="0"/>
-                <a:ea typeface="Calibri" pitchFamily="34" charset="-122"/>
-                <a:cs typeface="Calibri" pitchFamily="34" charset="-120"/>
-              </a:rPr>
-              <a:t>Spark    : 3.5.1</a:t>
-            </a:r>
-          </a:p>
-          <a:p>
-            <a:pPr algn="l" indent="0" marL="0">
-              <a:buNone/>
-            </a:pPr>
-            <a:r>
-              <a:rPr lang="en-US" sz="1200" dirty="0" b="0">
-                <a:solidFill>
-                  <a:srgbClr val="5B6B7A"/>
-                </a:solidFill>
-                <a:latin typeface="Consolas" pitchFamily="34" charset="0"/>
-                <a:ea typeface="Calibri" pitchFamily="34" charset="-122"/>
-                <a:cs typeface="Calibri" pitchFamily="34" charset="-120"/>
-              </a:rPr>
-              <a:t>Count    : 1000000 (mong đợi 1000000)</a:t>
+              <a:t>Count    : 1000000</a:t>
             </a:r>
           </a:p>
           <a:p>
@@ -3559,151 +2634,7 @@
                 <a:ea typeface="Calibri" pitchFamily="34" charset="-122"/>
                 <a:cs typeface="Calibri" pitchFamily="34" charset="-120"/>
               </a:rPr>
-              <a:t>RESULT   : PASS  (exit code 0)</a:t>
-            </a:r>
-          </a:p>
-          <a:p>
-            <a:pPr algn="l" indent="0" marL="0">
-              <a:buNone/>
-            </a:pPr>
-            <a:r>
-              <a:rPr lang="en-US" sz="1200" dirty="0" b="0">
-                <a:solidFill>
-                  <a:srgbClr val="5B6B7A"/>
-                </a:solidFill>
-                <a:latin typeface="Consolas" pitchFamily="34" charset="0"/>
-                <a:ea typeface="Calibri" pitchFamily="34" charset="-122"/>
-                <a:cs typeface="Calibri" pitchFamily="34" charset="-120"/>
-              </a:rPr>
-              <a:t/>
-            </a:r>
-          </a:p>
-          <a:p>
-            <a:pPr algn="l" indent="0" marL="0">
-              <a:buNone/>
-            </a:pPr>
-            <a:r>
-              <a:rPr lang="en-US" sz="1200" dirty="0" b="0">
-                <a:solidFill>
-                  <a:srgbClr val="5B6B7A"/>
-                </a:solidFill>
-                <a:latin typeface="Consolas" pitchFamily="34" charset="0"/>
-                <a:ea typeface="Calibri" pitchFamily="34" charset="-122"/>
-                <a:cs typeface="Calibri" pitchFamily="34" charset="-120"/>
-              </a:rPr>
-              <a:t>Điều kiện đã kiểm:</a:t>
-            </a:r>
-          </a:p>
-          <a:p>
-            <a:pPr algn="l" indent="0" marL="0">
-              <a:buNone/>
-            </a:pPr>
-            <a:r>
-              <a:rPr lang="en-US" sz="1200" dirty="0" b="0">
-                <a:solidFill>
-                  <a:srgbClr val="5B6B7A"/>
-                </a:solidFill>
-                <a:latin typeface="Consolas" pitchFamily="34" charset="0"/>
-                <a:ea typeface="Calibri" pitchFamily="34" charset="-122"/>
-                <a:cs typeface="Calibri" pitchFamily="34" charset="-120"/>
-              </a:rPr>
-              <a:t>  - .venv riêng, cài đủ từ requirements.txt</a:t>
-            </a:r>
-          </a:p>
-          <a:p>
-            <a:pPr algn="l" indent="0" marL="0">
-              <a:buNone/>
-            </a:pPr>
-            <a:r>
-              <a:rPr lang="en-US" sz="1200" dirty="0" b="0">
-                <a:solidFill>
-                  <a:srgbClr val="5B6B7A"/>
-                </a:solidFill>
-                <a:latin typeface="Consolas" pitchFamily="34" charset="0"/>
-                <a:ea typeface="Calibri" pitchFamily="34" charset="-122"/>
-                <a:cs typeface="Calibri" pitchFamily="34" charset="-120"/>
-              </a:rPr>
-              <a:t>  - JAVA_HOME trỏ JDK 17, không cài Spark</a:t>
-            </a:r>
-          </a:p>
-          <a:p>
-            <a:pPr algn="l" indent="0" marL="0">
-              <a:buNone/>
-            </a:pPr>
-            <a:r>
-              <a:rPr lang="en-US" sz="1200" dirty="0" b="0">
-                <a:solidFill>
-                  <a:srgbClr val="5B6B7A"/>
-                </a:solidFill>
-                <a:latin typeface="Consolas" pitchFamily="34" charset="0"/>
-                <a:ea typeface="Calibri" pitchFamily="34" charset="-122"/>
-                <a:cs typeface="Calibri" pitchFamily="34" charset="-120"/>
-              </a:rPr>
-              <a:t>    system-wide</a:t>
-            </a:r>
-          </a:p>
-          <a:p>
-            <a:pPr algn="l" indent="0" marL="0">
-              <a:buNone/>
-            </a:pPr>
-            <a:r>
-              <a:rPr lang="en-US" sz="1200" dirty="0" b="0">
-                <a:solidFill>
-                  <a:srgbClr val="5B6B7A"/>
-                </a:solidFill>
-                <a:latin typeface="Consolas" pitchFamily="34" charset="0"/>
-                <a:ea typeface="Calibri" pitchFamily="34" charset="-122"/>
-                <a:cs typeface="Calibri" pitchFamily="34" charset="-120"/>
-              </a:rPr>
-              <a:t>  - SparkSession local[*] khởi động được</a:t>
-            </a:r>
-          </a:p>
-          <a:p>
-            <a:pPr algn="l" indent="0" marL="0">
-              <a:buNone/>
-            </a:pPr>
-            <a:r>
-              <a:rPr lang="en-US" sz="1200" dirty="0" b="0">
-                <a:solidFill>
-                  <a:srgbClr val="5B6B7A"/>
-                </a:solidFill>
-                <a:latin typeface="Consolas" pitchFamily="34" charset="0"/>
-                <a:ea typeface="Calibri" pitchFamily="34" charset="-122"/>
-                <a:cs typeface="Calibri" pitchFamily="34" charset="-120"/>
-              </a:rPr>
-              <a:t>  - phép tính Spark trả đúng 1.000.000 dòng</a:t>
-            </a:r>
-          </a:p>
-          <a:p>
-            <a:pPr algn="l" indent="0" marL="0">
-              <a:buNone/>
-            </a:pPr>
-            <a:r>
-              <a:rPr lang="en-US" sz="1200" dirty="0" b="0">
-                <a:solidFill>
-                  <a:srgbClr val="5B6B7A"/>
-                </a:solidFill>
-                <a:latin typeface="Consolas" pitchFamily="34" charset="0"/>
-                <a:ea typeface="Calibri" pitchFamily="34" charset="-122"/>
-                <a:cs typeface="Calibri" pitchFamily="34" charset="-120"/>
-              </a:rPr>
-              <a:t/>
-            </a:r>
-          </a:p>
-          <a:p>
-            <a:pPr algn="l" indent="0" marL="0">
-              <a:buNone/>
-            </a:pPr>
-            <a:r>
-              <a:rPr lang="en-US" sz="1200" dirty="0" b="0">
-                <a:solidFill>
-                  <a:srgbClr val="5B6B7A"/>
-                </a:solidFill>
-                <a:latin typeface="Consolas" pitchFamily="34" charset="0"/>
-                <a:ea typeface="Calibri" pitchFamily="34" charset="-122"/>
-                <a:cs typeface="Calibri" pitchFamily="34" charset="-120"/>
-              </a:rPr>
-              <a:t>Kết luận: máy khác clone repo là chạy lại được.</a:t>
+              <a:t>RESULT   : PASS (exit 0)</a:t>
             </a:r>
           </a:p>
         </p:txBody>
@@ -3716,8 +2647,8 @@
         </p:nvSpPr>
         <p:spPr>
           <a:xfrm>
-            <a:off x="6263640" y="1828800"/>
-            <a:ext cx="5074920" cy="1411027"/>
+            <a:off x="6263640" y="1783080"/>
+            <a:ext cx="5074920" cy="1486487"/>
           </a:xfrm>
           <a:prstGeom prst="roundRect">
             <a:avLst>
@@ -3743,7 +2674,7 @@
         </p:nvSpPr>
         <p:spPr>
           <a:xfrm>
-            <a:off x="6519672" y="1956816"/>
+            <a:off x="6519672" y="1911096"/>
             <a:ext cx="4562856" cy="310896"/>
           </a:xfrm>
           <a:prstGeom prst="rect">
@@ -3784,7 +2715,7 @@
         </p:nvSpPr>
         <p:spPr>
           <a:xfrm>
-            <a:off x="6519672" y="2478266"/>
+            <a:off x="6519672" y="2331720"/>
             <a:ext cx="4562856" cy="496142"/>
           </a:xfrm>
           <a:prstGeom prst="rect">
@@ -3857,8 +2788,8 @@
         </p:nvSpPr>
         <p:spPr>
           <a:xfrm>
-            <a:off x="6263640" y="3422707"/>
-            <a:ext cx="5074920" cy="1292628"/>
+            <a:off x="6263640" y="3452447"/>
+            <a:ext cx="5074920" cy="1368088"/>
           </a:xfrm>
           <a:prstGeom prst="roundRect">
             <a:avLst>
@@ -3884,7 +2815,7 @@
         </p:nvSpPr>
         <p:spPr>
           <a:xfrm>
-            <a:off x="6519672" y="3550723"/>
+            <a:off x="6519672" y="3580463"/>
             <a:ext cx="4562856" cy="310896"/>
           </a:xfrm>
           <a:prstGeom prst="rect">
@@ -3925,7 +2856,7 @@
         </p:nvSpPr>
         <p:spPr>
           <a:xfrm>
-            <a:off x="6519672" y="4072173"/>
+            <a:off x="6519672" y="4001087"/>
             <a:ext cx="4562856" cy="377744"/>
           </a:xfrm>
           <a:prstGeom prst="rect">
@@ -3952,7 +2883,7 @@
                 <a:ea typeface="Calibri" pitchFamily="34" charset="-122"/>
                 <a:cs typeface="Calibri" pitchFamily="34" charset="-120"/>
               </a:rPr>
-              <a:t>local[*] trên Windows — Spark 3.5.1 + JDK 17</a:t>
+              <a:t>local[*] · Windows · Spark 3.5.1 + JDK 17</a:t>
             </a:r>
             <a:endParaRPr lang="en-US" sz="1300" dirty="0"/>
           </a:p>
@@ -3969,7 +2900,7 @@
                 <a:ea typeface="Calibri" pitchFamily="34" charset="-122"/>
                 <a:cs typeface="Calibri" pitchFamily="34" charset="-120"/>
               </a:rPr>
-              <a:t>16 GB RAM · 16 logical CPU · không Docker/cluster</a:t>
+              <a:t>16 GB RAM · 16 CPU · không Docker/cluster</a:t>
             </a:r>
           </a:p>
         </p:txBody>
@@ -3982,8 +2913,8 @@
         </p:nvSpPr>
         <p:spPr>
           <a:xfrm>
-            <a:off x="6263640" y="4898215"/>
-            <a:ext cx="5074920" cy="1456865"/>
+            <a:off x="6263640" y="5003415"/>
+            <a:ext cx="5074920" cy="1351665"/>
           </a:xfrm>
           <a:prstGeom prst="roundRect">
             <a:avLst>
@@ -4009,7 +2940,7 @@
         </p:nvSpPr>
         <p:spPr>
           <a:xfrm>
-            <a:off x="6519672" y="5026231"/>
+            <a:off x="6519672" y="5131431"/>
             <a:ext cx="4562856" cy="310896"/>
           </a:xfrm>
           <a:prstGeom prst="rect">
@@ -4036,7 +2967,7 @@
                 <a:ea typeface="Calibri" pitchFamily="34" charset="-122"/>
                 <a:cs typeface="Calibri" pitchFamily="34" charset="-120"/>
               </a:rPr>
-              <a:t>BLOCKER (nếu có)</a:t>
+              <a:t>BLOCKER (đã xử lý)</a:t>
             </a:r>
             <a:endParaRPr lang="en-US" sz="1600" dirty="0"/>
           </a:p>
@@ -4050,8 +2981,8 @@
         </p:nvSpPr>
         <p:spPr>
           <a:xfrm>
-            <a:off x="6519672" y="5547682"/>
-            <a:ext cx="4562856" cy="541980"/>
+            <a:off x="6519672" y="5552055"/>
+            <a:ext cx="4562856" cy="361320"/>
           </a:xfrm>
           <a:prstGeom prst="rect">
             <a:avLst/>
@@ -4077,7 +3008,7 @@
                 <a:ea typeface="Calibri" pitchFamily="34" charset="-122"/>
                 <a:cs typeface="Calibri" pitchFamily="34" charset="-120"/>
               </a:rPr>
-              <a:t>Thiếu winutils.exe khi Spark ghi Parquet trên Windows.</a:t>
+              <a:t>Thiếu winutils.exe khi Spark ghi Parquet.</a:t>
             </a:r>
             <a:endParaRPr lang="en-US" sz="1300" dirty="0"/>
           </a:p>
@@ -4094,7 +3025,7 @@
                 <a:ea typeface="Calibri" pitchFamily="34" charset="-122"/>
                 <a:cs typeface="Calibri" pitchFamily="34" charset="-120"/>
               </a:rPr>
-              <a:t>Đã xử lý: transform.py tự set HADOOP_HOME + PATH vào hadoop/bin trong repo — không cài Hadoop hệ thống.</a:t>
+              <a:t>transform.py tự set HADOOP_HOME + PATH vào hadoop/bin.</a:t>
             </a:r>
           </a:p>
         </p:txBody>
@@ -4208,55 +3139,14 @@
       </p:sp>
       <p:sp>
         <p:nvSpPr>
-          <p:cNvPr id="4" name="Text 2"/>
-          <p:cNvSpPr/>
-          <p:nvPr/>
-        </p:nvSpPr>
-        <p:spPr>
-          <a:xfrm>
-            <a:off x="594360" y="1261872"/>
-            <a:ext cx="10972800" cy="310896"/>
-          </a:xfrm>
-          <a:prstGeom prst="rect">
-            <a:avLst/>
-          </a:prstGeom>
-          <a:noFill/>
-          <a:ln/>
-        </p:spPr>
-        <p:txBody>
-          <a:bodyPr wrap="square" lIns="0" tIns="0" rIns="0" bIns="0" rtlCol="0" anchor="ctr">
-            <a:normAutofit/>
-          </a:bodyPr>
-          <a:lstStyle/>
-          <a:p>
-            <a:pPr algn="l" indent="0" marL="0">
-              <a:buNone/>
-            </a:pPr>
-            <a:r>
-              <a:rPr lang="en-US" sz="1400" dirty="0">
-                <a:solidFill>
-                  <a:srgbClr val="5B6B7A"/>
-                </a:solidFill>
-                <a:latin typeface="Calibri" pitchFamily="34" charset="0"/>
-                <a:ea typeface="Calibri" pitchFamily="34" charset="-122"/>
-                <a:cs typeface="Calibri" pitchFamily="34" charset="-120"/>
-              </a:rPr>
-              <a:t>Nguồn dữ liệu phải cụ thể và job phải chạy được.</a:t>
-            </a:r>
-            <a:endParaRPr lang="en-US" sz="1400" dirty="0"/>
-          </a:p>
-        </p:txBody>
-      </p:sp>
-      <p:sp>
-        <p:nvSpPr>
           <p:cNvPr id="5" name="Shape 3"/>
           <p:cNvSpPr/>
           <p:nvPr/>
         </p:nvSpPr>
         <p:spPr>
           <a:xfrm>
-            <a:off x="777240" y="1828800"/>
-            <a:ext cx="5074920" cy="1466535"/>
+            <a:off x="777240" y="1783080"/>
+            <a:ext cx="5074920" cy="1541995"/>
           </a:xfrm>
           <a:prstGeom prst="roundRect">
             <a:avLst>
@@ -4282,7 +3172,7 @@
         </p:nvSpPr>
         <p:spPr>
           <a:xfrm>
-            <a:off x="1033272" y="1956816"/>
+            <a:off x="1033272" y="1911096"/>
             <a:ext cx="4562856" cy="310896"/>
           </a:xfrm>
           <a:prstGeom prst="rect">
@@ -4323,7 +3213,7 @@
         </p:nvSpPr>
         <p:spPr>
           <a:xfrm>
-            <a:off x="1033272" y="2423330"/>
+            <a:off x="1033272" y="2331720"/>
             <a:ext cx="4562856" cy="661523"/>
           </a:xfrm>
           <a:prstGeom prst="rect">
@@ -4350,7 +3240,7 @@
                 <a:ea typeface="Calibri" pitchFamily="34" charset="-122"/>
                 <a:cs typeface="Calibri" pitchFamily="34" charset="-120"/>
               </a:rPr>
-              <a:t>Dataset: Trending YouTube Videos (113 countries)</a:t>
+              <a:t>Kaggle — Trending YouTube Videos (113 countries)</a:t>
             </a:r>
             <a:endParaRPr lang="en-US" sz="1300" dirty="0"/>
           </a:p>
@@ -4367,7 +3257,7 @@
                 <a:ea typeface="Calibri" pitchFamily="34" charset="-122"/>
                 <a:cs typeface="Calibri" pitchFamily="34" charset="-120"/>
               </a:rPr>
-              <a:t>https://www.kaggle.com/datasets/asaniczka/</a:t>
+              <a:t>kaggle.com/datasets/asaniczka/</a:t>
             </a:r>
           </a:p>
           <a:p>
@@ -4399,7 +3289,7 @@
                 <a:ea typeface="Calibri" pitchFamily="34" charset="-122"/>
                 <a:cs typeface="Calibri" pitchFamily="34" charset="-120"/>
               </a:rPr>
-              <a:t>tải về 2026-10-20 · giữ 1 file gốc, không sửa</a:t>
+              <a:t>License ODC-By · tải 2026-10-20</a:t>
             </a:r>
           </a:p>
         </p:txBody>
@@ -4412,8 +3302,8 @@
         </p:nvSpPr>
         <p:spPr>
           <a:xfrm>
-            <a:off x="777240" y="3478215"/>
-            <a:ext cx="5074920" cy="1346992"/>
+            <a:off x="777240" y="3507955"/>
+            <a:ext cx="5074920" cy="1422452"/>
           </a:xfrm>
           <a:prstGeom prst="roundRect">
             <a:avLst>
@@ -4439,7 +3329,7 @@
         </p:nvSpPr>
         <p:spPr>
           <a:xfrm>
-            <a:off x="1033272" y="3606231"/>
+            <a:off x="1033272" y="3635971"/>
             <a:ext cx="4562856" cy="310896"/>
           </a:xfrm>
           <a:prstGeom prst="rect">
@@ -4480,7 +3370,7 @@
         </p:nvSpPr>
         <p:spPr>
           <a:xfrm>
-            <a:off x="1033272" y="4072745"/>
+            <a:off x="1033272" y="4056595"/>
             <a:ext cx="4562856" cy="541980"/>
           </a:xfrm>
           <a:prstGeom prst="rect">
@@ -4553,8 +3443,8 @@
         </p:nvSpPr>
         <p:spPr>
           <a:xfrm>
-            <a:off x="777240" y="5008088"/>
-            <a:ext cx="5074920" cy="1346992"/>
+            <a:off x="777240" y="5113288"/>
+            <a:ext cx="5074920" cy="1241792"/>
           </a:xfrm>
           <a:prstGeom prst="roundRect">
             <a:avLst>
@@ -4580,7 +3470,7 @@
         </p:nvSpPr>
         <p:spPr>
           <a:xfrm>
-            <a:off x="1033272" y="5136104"/>
+            <a:off x="1033272" y="5241304"/>
             <a:ext cx="4562856" cy="310896"/>
           </a:xfrm>
           <a:prstGeom prst="rect">
@@ -4621,8 +3511,8 @@
         </p:nvSpPr>
         <p:spPr>
           <a:xfrm>
-            <a:off x="1033272" y="5602618"/>
-            <a:ext cx="4562856" cy="541980"/>
+            <a:off x="1033272" y="5661928"/>
+            <a:ext cx="4562856" cy="361320"/>
           </a:xfrm>
           <a:prstGeom prst="rect">
             <a:avLst/>
@@ -4648,7 +3538,7 @@
                 <a:ea typeface="Calibri" pitchFamily="34" charset="-122"/>
                 <a:cs typeface="Calibri" pitchFamily="34" charset="-120"/>
               </a:rPr>
-              <a:t>Kaggle · license ODC-By · ghi rõ nguồn khi dùng lại.</a:t>
+              <a:t>Copy nguyên bản + SHA-256 + manifest</a:t>
             </a:r>
             <a:endParaRPr lang="en-US" sz="1300" dirty="0"/>
           </a:p>
@@ -4665,23 +3555,7 @@
                 <a:ea typeface="Calibri" pitchFamily="34" charset="-122"/>
                 <a:cs typeface="Calibri" pitchFamily="34" charset="-120"/>
               </a:rPr>
-              <a:t>ingest = copy + SHA-256 + manifest → truy ngược được từng byte trong raw.</a:t>
-            </a:r>
-          </a:p>
-          <a:p>
-            <a:pPr algn="l" indent="0" marL="0">
-              <a:buNone/>
-            </a:pPr>
-            <a:r>
-              <a:rPr lang="en-US" sz="1100" dirty="0" b="0">
-                <a:solidFill>
-                  <a:srgbClr val="5B6B7A"/>
-                </a:solidFill>
-                <a:latin typeface="Calibri" pitchFamily="34" charset="0"/>
-                <a:ea typeface="Calibri" pitchFamily="34" charset="-122"/>
-                <a:cs typeface="Calibri" pitchFamily="34" charset="-120"/>
-              </a:rPr>
-              <a:t>File 8,59 GB không commit; chỉ commit manifest + log.</a:t>
+              <a:t>Raw không sửa 1 byte · file lớn không commit</a:t>
             </a:r>
           </a:p>
         </p:txBody>
@@ -4694,8 +3568,8 @@
         </p:nvSpPr>
         <p:spPr>
           <a:xfrm>
-            <a:off x="6263640" y="1828800"/>
-            <a:ext cx="5074920" cy="4526280"/>
+            <a:off x="6263640" y="1783080"/>
+            <a:ext cx="5074920" cy="4572000"/>
           </a:xfrm>
           <a:prstGeom prst="roundRect">
             <a:avLst>
@@ -4721,7 +3595,7 @@
         </p:nvSpPr>
         <p:spPr>
           <a:xfrm>
-            <a:off x="6519672" y="1956816"/>
+            <a:off x="6519672" y="1911096"/>
             <a:ext cx="4562856" cy="310896"/>
           </a:xfrm>
           <a:prstGeom prst="rect">
@@ -4762,8 +3636,8 @@
         </p:nvSpPr>
         <p:spPr>
           <a:xfrm>
-            <a:off x="6519672" y="2464777"/>
-            <a:ext cx="4562856" cy="3638375"/>
+            <a:off x="6519672" y="2331720"/>
+            <a:ext cx="4562856" cy="2425583"/>
           </a:xfrm>
           <a:prstGeom prst="rect">
             <a:avLst/>
@@ -4838,7 +3712,7 @@
                 <a:ea typeface="Calibri" pitchFamily="34" charset="-122"/>
                 <a:cs typeface="Calibri" pitchFamily="34" charset="-120"/>
               </a:rPr>
-              <a:t>2026-10-20T14:30:40 | success | files=1</a:t>
+              <a:t>success | files=1</a:t>
             </a:r>
           </a:p>
           <a:p>
@@ -4878,239 +3752,127 @@
               <a:buNone/>
             </a:pPr>
             <a:r>
+              <a:rPr lang="en-US" sz="1100" dirty="0" b="0">
+                <a:solidFill>
+                  <a:srgbClr val="5B6B7A"/>
+                </a:solidFill>
+                <a:latin typeface="Consolas" pitchFamily="34" charset="0"/>
+                <a:ea typeface="Calibri" pitchFamily="34" charset="-122"/>
+                <a:cs typeface="Calibri" pitchFamily="34" charset="-120"/>
+              </a:rPr>
+              <a:t>  run=run_20261020T143013Z</a:t>
+            </a:r>
+          </a:p>
+          <a:p>
+            <a:pPr algn="l" indent="0" marL="0">
+              <a:buNone/>
+            </a:pPr>
+            <a:r>
+              <a:rPr lang="en-US" sz="1100" dirty="0" b="0">
+                <a:solidFill>
+                  <a:srgbClr val="5B6B7A"/>
+                </a:solidFill>
+                <a:latin typeface="Consolas" pitchFamily="34" charset="0"/>
+                <a:ea typeface="Calibri" pitchFamily="34" charset="-122"/>
+                <a:cs typeface="Calibri" pitchFamily="34" charset="-120"/>
+              </a:rPr>
+              <a:t/>
+            </a:r>
+          </a:p>
+          <a:p>
+            <a:pPr algn="l" indent="0" marL="0">
+              <a:buNone/>
+            </a:pPr>
+            <a:r>
+              <a:rPr lang="en-US" sz="1100" dirty="0" b="0">
+                <a:solidFill>
+                  <a:srgbClr val="5B6B7A"/>
+                </a:solidFill>
+                <a:latin typeface="Consolas" pitchFamily="34" charset="0"/>
+                <a:ea typeface="Calibri" pitchFamily="34" charset="-122"/>
+                <a:cs typeface="Calibri" pitchFamily="34" charset="-120"/>
+              </a:rPr>
+              <a:t>$ python src\verify_raw_records.py</a:t>
+            </a:r>
+          </a:p>
+          <a:p>
+            <a:pPr algn="l" indent="0" marL="0">
+              <a:buNone/>
+            </a:pPr>
+            <a:r>
+              <a:rPr lang="en-US" sz="1100" dirty="0" b="0">
+                <a:solidFill>
+                  <a:srgbClr val="5B6B7A"/>
+                </a:solidFill>
+                <a:latin typeface="Consolas" pitchFamily="34" charset="0"/>
+                <a:ea typeface="Calibri" pitchFamily="34" charset="-122"/>
+                <a:cs typeface="Calibri" pitchFamily="34" charset="-120"/>
+              </a:rPr>
+              <a:t>  records=6,094,047</a:t>
+            </a:r>
+          </a:p>
+          <a:p>
+            <a:pPr algn="l" indent="0" marL="0">
+              <a:buNone/>
+            </a:pPr>
+            <a:r>
+              <a:rPr lang="en-US" sz="1100" dirty="0" b="0">
+                <a:solidFill>
+                  <a:srgbClr val="5B6B7A"/>
+                </a:solidFill>
+                <a:latin typeface="Consolas" pitchFamily="34" charset="0"/>
+                <a:ea typeface="Calibri" pitchFamily="34" charset="-122"/>
+                <a:cs typeface="Calibri" pitchFamily="34" charset="-120"/>
+              </a:rPr>
+              <a:t>  physical_lines=134,442,959</a:t>
+            </a:r>
+          </a:p>
+          <a:p>
+            <a:pPr algn="l" indent="0" marL="0">
+              <a:buNone/>
+            </a:pPr>
+            <a:r>
+              <a:rPr lang="en-US" sz="1100" dirty="0" b="0">
+                <a:solidFill>
+                  <a:srgbClr val="5B6B7A"/>
+                </a:solidFill>
+                <a:latin typeface="Consolas" pitchFamily="34" charset="0"/>
+                <a:ea typeface="Calibri" pitchFamily="34" charset="-122"/>
+                <a:cs typeface="Calibri" pitchFamily="34" charset="-120"/>
+              </a:rPr>
+              <a:t>  multi_line=True</a:t>
+            </a:r>
+          </a:p>
+          <a:p>
+            <a:pPr algn="l" indent="0" marL="0">
+              <a:buNone/>
+            </a:pPr>
+            <a:r>
+              <a:rPr lang="en-US" sz="1100" dirty="0" b="0">
+                <a:solidFill>
+                  <a:srgbClr val="5B6B7A"/>
+                </a:solidFill>
+                <a:latin typeface="Consolas" pitchFamily="34" charset="0"/>
+                <a:ea typeface="Calibri" pitchFamily="34" charset="-122"/>
+                <a:cs typeface="Calibri" pitchFamily="34" charset="-120"/>
+              </a:rPr>
+              <a:t/>
+            </a:r>
+          </a:p>
+          <a:p>
+            <a:pPr algn="l" indent="0" marL="0">
+              <a:buNone/>
+            </a:pPr>
+            <a:r>
               <a:rPr lang="en-US" sz="1100" dirty="0" b="1">
                 <a:solidFill>
-                  <a:srgbClr val="5B6B7A"/>
-                </a:solidFill>
-                <a:latin typeface="Consolas" pitchFamily="34" charset="0"/>
-                <a:ea typeface="Calibri" pitchFamily="34" charset="-122"/>
-                <a:cs typeface="Calibri" pitchFamily="34" charset="-120"/>
-              </a:rPr>
-              <a:t>  run=run_20261020T143013Z</a:t>
-            </a:r>
-          </a:p>
-          <a:p>
-            <a:pPr algn="l" indent="0" marL="0">
-              <a:buNone/>
-            </a:pPr>
-            <a:r>
-              <a:rPr lang="en-US" sz="1100" dirty="0" b="0">
-                <a:solidFill>
-                  <a:srgbClr val="5B6B7A"/>
-                </a:solidFill>
-                <a:latin typeface="Consolas" pitchFamily="34" charset="0"/>
-                <a:ea typeface="Calibri" pitchFamily="34" charset="-122"/>
-                <a:cs typeface="Calibri" pitchFamily="34" charset="-120"/>
-              </a:rPr>
-              <a:t>2026-10-20T14:30:40 | manifest</a:t>
-            </a:r>
-          </a:p>
-          <a:p>
-            <a:pPr algn="l" indent="0" marL="0">
-              <a:buNone/>
-            </a:pPr>
-            <a:r>
-              <a:rPr lang="en-US" sz="1100" dirty="0" b="0">
-                <a:solidFill>
-                  <a:srgbClr val="5B6B7A"/>
-                </a:solidFill>
-                <a:latin typeface="Consolas" pitchFamily="34" charset="0"/>
-                <a:ea typeface="Calibri" pitchFamily="34" charset="-122"/>
-                <a:cs typeface="Calibri" pitchFamily="34" charset="-120"/>
-              </a:rPr>
-              <a:t>  data\raw\youtube_trending\</a:t>
-            </a:r>
-          </a:p>
-          <a:p>
-            <a:pPr algn="l" indent="0" marL="0">
-              <a:buNone/>
-            </a:pPr>
-            <a:r>
-              <a:rPr lang="en-US" sz="1100" dirty="0" b="0">
-                <a:solidFill>
-                  <a:srgbClr val="5B6B7A"/>
-                </a:solidFill>
-                <a:latin typeface="Consolas" pitchFamily="34" charset="0"/>
-                <a:ea typeface="Calibri" pitchFamily="34" charset="-122"/>
-                <a:cs typeface="Calibri" pitchFamily="34" charset="-120"/>
-              </a:rPr>
-              <a:t>    ingest_date=2026-10-20\run_20261020T143013Z\</a:t>
-            </a:r>
-          </a:p>
-          <a:p>
-            <a:pPr algn="l" indent="0" marL="0">
-              <a:buNone/>
-            </a:pPr>
-            <a:r>
-              <a:rPr lang="en-US" sz="1100" dirty="0" b="0">
-                <a:solidFill>
-                  <a:srgbClr val="5B6B7A"/>
-                </a:solidFill>
-                <a:latin typeface="Consolas" pitchFamily="34" charset="0"/>
-                <a:ea typeface="Calibri" pitchFamily="34" charset="-122"/>
-                <a:cs typeface="Calibri" pitchFamily="34" charset="-120"/>
-              </a:rPr>
-              <a:t>    manifest.json</a:t>
-            </a:r>
-          </a:p>
-          <a:p>
-            <a:pPr algn="l" indent="0" marL="0">
-              <a:buNone/>
-            </a:pPr>
-            <a:r>
-              <a:rPr lang="en-US" sz="1100" dirty="0" b="0">
-                <a:solidFill>
-                  <a:srgbClr val="5B6B7A"/>
-                </a:solidFill>
-                <a:latin typeface="Consolas" pitchFamily="34" charset="0"/>
-                <a:ea typeface="Calibri" pitchFamily="34" charset="-122"/>
-                <a:cs typeface="Calibri" pitchFamily="34" charset="-120"/>
-              </a:rPr>
-              <a:t/>
-            </a:r>
-          </a:p>
-          <a:p>
-            <a:pPr algn="l" indent="0" marL="0">
-              <a:buNone/>
-            </a:pPr>
-            <a:r>
-              <a:rPr lang="en-US" sz="1100" dirty="0" b="0">
-                <a:solidFill>
-                  <a:srgbClr val="5B6B7A"/>
-                </a:solidFill>
-                <a:latin typeface="Consolas" pitchFamily="34" charset="0"/>
-                <a:ea typeface="Calibri" pitchFamily="34" charset="-122"/>
-                <a:cs typeface="Calibri" pitchFamily="34" charset="-120"/>
-              </a:rPr>
-              <a:t>$ python src\verify_raw_records.py</a:t>
-            </a:r>
-          </a:p>
-          <a:p>
-            <a:pPr algn="l" indent="0" marL="0">
-              <a:buNone/>
-            </a:pPr>
-            <a:r>
-              <a:rPr lang="en-US" sz="1100" dirty="0" b="0">
-                <a:solidFill>
-                  <a:srgbClr val="5B6B7A"/>
-                </a:solidFill>
-                <a:latin typeface="Consolas" pitchFamily="34" charset="0"/>
-                <a:ea typeface="Calibri" pitchFamily="34" charset="-122"/>
-                <a:cs typeface="Calibri" pitchFamily="34" charset="-120"/>
-              </a:rPr>
-              <a:t>2026-10-21T17:20:17 | verify_records</a:t>
-            </a:r>
-          </a:p>
-          <a:p>
-            <a:pPr algn="l" indent="0" marL="0">
-              <a:buNone/>
-            </a:pPr>
-            <a:r>
-              <a:rPr lang="en-US" sz="1100" dirty="0" b="0">
-                <a:solidFill>
-                  <a:srgbClr val="5B6B7A"/>
-                </a:solidFill>
-                <a:latin typeface="Consolas" pitchFamily="34" charset="0"/>
-                <a:ea typeface="Calibri" pitchFamily="34" charset="-122"/>
-                <a:cs typeface="Calibri" pitchFamily="34" charset="-120"/>
-              </a:rPr>
-              <a:t>  records=6,094,047</a:t>
-            </a:r>
-          </a:p>
-          <a:p>
-            <a:pPr algn="l" indent="0" marL="0">
-              <a:buNone/>
-            </a:pPr>
-            <a:r>
-              <a:rPr lang="en-US" sz="1100" dirty="0" b="0">
-                <a:solidFill>
-                  <a:srgbClr val="5B6B7A"/>
-                </a:solidFill>
-                <a:latin typeface="Consolas" pitchFamily="34" charset="0"/>
-                <a:ea typeface="Calibri" pitchFamily="34" charset="-122"/>
-                <a:cs typeface="Calibri" pitchFamily="34" charset="-120"/>
-              </a:rPr>
-              <a:t>  physical_lines=134,442,959 (multi_line=True)</a:t>
-            </a:r>
-          </a:p>
-          <a:p>
-            <a:pPr algn="l" indent="0" marL="0">
-              <a:buNone/>
-            </a:pPr>
-            <a:r>
-              <a:rPr lang="en-US" sz="1100" dirty="0" b="0">
-                <a:solidFill>
-                  <a:srgbClr val="5B6B7A"/>
-                </a:solidFill>
-                <a:latin typeface="Consolas" pitchFamily="34" charset="0"/>
-                <a:ea typeface="Calibri" pitchFamily="34" charset="-122"/>
-                <a:cs typeface="Calibri" pitchFamily="34" charset="-120"/>
-              </a:rPr>
-              <a:t/>
-            </a:r>
-          </a:p>
-          <a:p>
-            <a:pPr algn="l" indent="0" marL="0">
-              <a:buNone/>
-            </a:pPr>
-            <a:r>
-              <a:rPr lang="en-US" sz="1100" dirty="0" b="0">
-                <a:solidFill>
-                  <a:srgbClr val="5B6B7A"/>
-                </a:solidFill>
-                <a:latin typeface="Consolas" pitchFamily="34" charset="0"/>
-                <a:ea typeface="Calibri" pitchFamily="34" charset="-122"/>
-                <a:cs typeface="Calibri" pitchFamily="34" charset="-120"/>
-              </a:rPr>
-              <a:t>Chạy lại 3 lần cùng file: duplicate_skip x3</a:t>
-            </a:r>
-          </a:p>
-          <a:p>
-            <a:pPr algn="l" indent="0" marL="0">
-              <a:buNone/>
-            </a:pPr>
-            <a:r>
-              <a:rPr lang="en-US" sz="1100" dirty="0" b="1">
-                <a:solidFill>
                   <a:srgbClr val="0E7C4A"/>
                 </a:solidFill>
                 <a:latin typeface="Consolas" pitchFamily="34" charset="0"/>
                 <a:ea typeface="Calibri" pitchFamily="34" charset="-122"/>
                 <a:cs typeface="Calibri" pitchFamily="34" charset="-120"/>
               </a:rPr>
-              <a:t>→ raw KHÔNG đổi, vẫn đúng 1 run</a:t>
-            </a:r>
-          </a:p>
-          <a:p>
-            <a:pPr algn="l" indent="0" marL="0">
-              <a:buNone/>
-            </a:pPr>
-            <a:r>
-              <a:rPr lang="en-US" sz="1100" dirty="0" b="0">
-                <a:solidFill>
-                  <a:srgbClr val="5B6B7A"/>
-                </a:solidFill>
-                <a:latin typeface="Consolas" pitchFamily="34" charset="0"/>
-                <a:ea typeface="Calibri" pitchFamily="34" charset="-122"/>
-                <a:cs typeface="Calibri" pitchFamily="34" charset="-120"/>
-              </a:rPr>
-              <a:t/>
-            </a:r>
-          </a:p>
-          <a:p>
-            <a:pPr algn="l" indent="0" marL="0">
-              <a:buNone/>
-            </a:pPr>
-            <a:r>
-              <a:rPr lang="en-US" sz="1100" dirty="0" b="0">
-                <a:solidFill>
-                  <a:srgbClr val="5B6B7A"/>
-                </a:solidFill>
-                <a:latin typeface="Consolas" pitchFamily="34" charset="0"/>
-                <a:ea typeface="Calibri" pitchFamily="34" charset="-122"/>
-                <a:cs typeface="Calibri" pitchFamily="34" charset="-120"/>
-              </a:rPr>
-              <a:t>Exit code = 0 · raw chỉ được ghi 1 lần.</a:t>
+              <a:t>Exit code = 0</a:t>
             </a:r>
           </a:p>
         </p:txBody>
@@ -5224,55 +3986,14 @@
       </p:sp>
       <p:sp>
         <p:nvSpPr>
-          <p:cNvPr id="4" name="Text 2"/>
-          <p:cNvSpPr/>
-          <p:nvPr/>
-        </p:nvSpPr>
-        <p:spPr>
-          <a:xfrm>
-            <a:off x="594360" y="1261872"/>
-            <a:ext cx="10972800" cy="310896"/>
-          </a:xfrm>
-          <a:prstGeom prst="rect">
-            <a:avLst/>
-          </a:prstGeom>
-          <a:noFill/>
-          <a:ln/>
-        </p:spPr>
-        <p:txBody>
-          <a:bodyPr wrap="square" lIns="0" tIns="0" rIns="0" bIns="0" rtlCol="0" anchor="ctr">
-            <a:normAutofit/>
-          </a:bodyPr>
-          <a:lstStyle/>
-          <a:p>
-            <a:pPr algn="l" indent="0" marL="0">
-              <a:buNone/>
-            </a:pPr>
-            <a:r>
-              <a:rPr lang="en-US" sz="1400" dirty="0">
-                <a:solidFill>
-                  <a:srgbClr val="5B6B7A"/>
-                </a:solidFill>
-                <a:latin typeface="Calibri" pitchFamily="34" charset="0"/>
-                <a:ea typeface="Calibri" pitchFamily="34" charset="-122"/>
-                <a:cs typeface="Calibri" pitchFamily="34" charset="-120"/>
-              </a:rPr>
-              <a:t>Show path thật, không chỉ mô tả.</a:t>
-            </a:r>
-            <a:endParaRPr lang="en-US" sz="1400" dirty="0"/>
-          </a:p>
-        </p:txBody>
-      </p:sp>
-      <p:sp>
-        <p:nvSpPr>
           <p:cNvPr id="5" name="Shape 3"/>
           <p:cNvSpPr/>
           <p:nvPr/>
         </p:nvSpPr>
         <p:spPr>
           <a:xfrm>
-            <a:off x="777240" y="1828800"/>
-            <a:ext cx="5303520" cy="4526280"/>
+            <a:off x="777240" y="1783080"/>
+            <a:ext cx="5303520" cy="4572000"/>
           </a:xfrm>
           <a:prstGeom prst="roundRect">
             <a:avLst>
@@ -5298,7 +4019,7 @@
         </p:nvSpPr>
         <p:spPr>
           <a:xfrm>
-            <a:off x="1033272" y="1956816"/>
+            <a:off x="1033272" y="1911096"/>
             <a:ext cx="4791456" cy="310896"/>
           </a:xfrm>
           <a:prstGeom prst="rect">
@@ -5339,8 +4060,8 @@
         </p:nvSpPr>
         <p:spPr>
           <a:xfrm>
-            <a:off x="1033272" y="2984544"/>
-            <a:ext cx="4791456" cy="2598839"/>
+            <a:off x="1033272" y="2331720"/>
+            <a:ext cx="4791456" cy="1323045"/>
           </a:xfrm>
           <a:prstGeom prst="rect">
             <a:avLst/>
@@ -5358,15 +4079,15 @@
               <a:buNone/>
             </a:pPr>
             <a:r>
-              <a:rPr lang="en-US" sz="1100" dirty="0" b="0">
-                <a:solidFill>
-                  <a:srgbClr val="5B6B7A"/>
-                </a:solidFill>
-                <a:latin typeface="Consolas" pitchFamily="34" charset="0"/>
-                <a:ea typeface="Calibri" pitchFamily="34" charset="-122"/>
-                <a:cs typeface="Calibri" pitchFamily="34" charset="-120"/>
-              </a:rPr>
-              <a:t>data/raw/</a:t>
+              <a:rPr lang="en-US" sz="1050" dirty="0" b="0">
+                <a:solidFill>
+                  <a:srgbClr val="5B6B7A"/>
+                </a:solidFill>
+                <a:latin typeface="Consolas" pitchFamily="34" charset="0"/>
+                <a:ea typeface="Calibri" pitchFamily="34" charset="-122"/>
+                <a:cs typeface="Calibri" pitchFamily="34" charset="-120"/>
+              </a:rPr>
+              <a:t>data/raw/youtube_trending/</a:t>
             </a:r>
             <a:endParaRPr lang="en-US" sz="1300" dirty="0"/>
           </a:p>
@@ -5375,103 +4096,87 @@
               <a:buNone/>
             </a:pPr>
             <a:r>
-              <a:rPr lang="en-US" sz="1100" dirty="0" b="0">
-                <a:solidFill>
-                  <a:srgbClr val="5B6B7A"/>
-                </a:solidFill>
-                <a:latin typeface="Consolas" pitchFamily="34" charset="0"/>
-                <a:ea typeface="Calibri" pitchFamily="34" charset="-122"/>
-                <a:cs typeface="Calibri" pitchFamily="34" charset="-120"/>
-              </a:rPr>
-              <a:t>  youtube_trending/</a:t>
-            </a:r>
-          </a:p>
-          <a:p>
-            <a:pPr algn="l" indent="0" marL="0">
-              <a:buNone/>
-            </a:pPr>
-            <a:r>
-              <a:rPr lang="en-US" sz="1100" dirty="0" b="0">
-                <a:solidFill>
-                  <a:srgbClr val="5B6B7A"/>
-                </a:solidFill>
-                <a:latin typeface="Consolas" pitchFamily="34" charset="0"/>
-                <a:ea typeface="Calibri" pitchFamily="34" charset="-122"/>
-                <a:cs typeface="Calibri" pitchFamily="34" charset="-120"/>
-              </a:rPr>
-              <a:t>    ingest_date=2026-10-20/</a:t>
-            </a:r>
-          </a:p>
-          <a:p>
-            <a:pPr algn="l" indent="0" marL="0">
-              <a:buNone/>
-            </a:pPr>
-            <a:r>
-              <a:rPr lang="en-US" sz="1100" dirty="0" b="0">
-                <a:solidFill>
-                  <a:srgbClr val="5B6B7A"/>
-                </a:solidFill>
-                <a:latin typeface="Consolas" pitchFamily="34" charset="0"/>
-                <a:ea typeface="Calibri" pitchFamily="34" charset="-122"/>
-                <a:cs typeface="Calibri" pitchFamily="34" charset="-120"/>
-              </a:rPr>
-              <a:t>      run_20261020T143013Z/</a:t>
-            </a:r>
-          </a:p>
-          <a:p>
-            <a:pPr algn="l" indent="0" marL="0">
-              <a:buNone/>
-            </a:pPr>
-            <a:r>
-              <a:rPr lang="en-US" sz="1100" dirty="0" b="0">
-                <a:solidFill>
-                  <a:srgbClr val="5B6B7A"/>
-                </a:solidFill>
-                <a:latin typeface="Consolas" pitchFamily="34" charset="0"/>
-                <a:ea typeface="Calibri" pitchFamily="34" charset="-122"/>
-                <a:cs typeface="Calibri" pitchFamily="34" charset="-120"/>
-              </a:rPr>
-              <a:t>        trending_yt_videos_113_countries.csv</a:t>
-            </a:r>
-          </a:p>
-          <a:p>
-            <a:pPr algn="l" indent="0" marL="0">
-              <a:buNone/>
-            </a:pPr>
-            <a:r>
-              <a:rPr lang="en-US" sz="1100" dirty="0" b="0">
-                <a:solidFill>
-                  <a:srgbClr val="5B6B7A"/>
-                </a:solidFill>
-                <a:latin typeface="Consolas" pitchFamily="34" charset="0"/>
-                <a:ea typeface="Calibri" pitchFamily="34" charset="-122"/>
-                <a:cs typeface="Calibri" pitchFamily="34" charset="-120"/>
-              </a:rPr>
-              <a:t>          8.591.418.141 bytes (8,59 GB)</a:t>
-            </a:r>
-          </a:p>
-          <a:p>
-            <a:pPr algn="l" indent="0" marL="0">
-              <a:buNone/>
-            </a:pPr>
-            <a:r>
-              <a:rPr lang="en-US" sz="1100" dirty="0" b="0">
-                <a:solidFill>
-                  <a:srgbClr val="5B6B7A"/>
-                </a:solidFill>
-                <a:latin typeface="Consolas" pitchFamily="34" charset="0"/>
-                <a:ea typeface="Calibri" pitchFamily="34" charset="-122"/>
-                <a:cs typeface="Calibri" pitchFamily="34" charset="-120"/>
-              </a:rPr>
-              <a:t>        manifest.json   (status: success)</a:t>
-            </a:r>
-          </a:p>
-          <a:p>
-            <a:pPr algn="l" indent="0" marL="0">
-              <a:buNone/>
-            </a:pPr>
-            <a:r>
-              <a:rPr lang="en-US" sz="1100" dirty="0" b="0">
+              <a:rPr lang="en-US" sz="1050" dirty="0" b="0">
+                <a:solidFill>
+                  <a:srgbClr val="5B6B7A"/>
+                </a:solidFill>
+                <a:latin typeface="Consolas" pitchFamily="34" charset="0"/>
+                <a:ea typeface="Calibri" pitchFamily="34" charset="-122"/>
+                <a:cs typeface="Calibri" pitchFamily="34" charset="-120"/>
+              </a:rPr>
+              <a:t>  ingest_date=2026-10-20/</a:t>
+            </a:r>
+          </a:p>
+          <a:p>
+            <a:pPr algn="l" indent="0" marL="0">
+              <a:buNone/>
+            </a:pPr>
+            <a:r>
+              <a:rPr lang="en-US" sz="1050" dirty="0" b="0">
+                <a:solidFill>
+                  <a:srgbClr val="5B6B7A"/>
+                </a:solidFill>
+                <a:latin typeface="Consolas" pitchFamily="34" charset="0"/>
+                <a:ea typeface="Calibri" pitchFamily="34" charset="-122"/>
+                <a:cs typeface="Calibri" pitchFamily="34" charset="-120"/>
+              </a:rPr>
+              <a:t>    run_20261020T143013Z/</a:t>
+            </a:r>
+          </a:p>
+          <a:p>
+            <a:pPr algn="l" indent="0" marL="0">
+              <a:buNone/>
+            </a:pPr>
+            <a:r>
+              <a:rPr lang="en-US" sz="1050" dirty="0" b="0">
+                <a:solidFill>
+                  <a:srgbClr val="5B6B7A"/>
+                </a:solidFill>
+                <a:latin typeface="Consolas" pitchFamily="34" charset="0"/>
+                <a:ea typeface="Calibri" pitchFamily="34" charset="-122"/>
+                <a:cs typeface="Calibri" pitchFamily="34" charset="-120"/>
+              </a:rPr>
+              <a:t>      trending_yt_videos_113_countries.csv</a:t>
+            </a:r>
+          </a:p>
+          <a:p>
+            <a:pPr algn="l" indent="0" marL="0">
+              <a:buNone/>
+            </a:pPr>
+            <a:r>
+              <a:rPr lang="en-US" sz="1050" dirty="0" b="0">
+                <a:solidFill>
+                  <a:srgbClr val="5B6B7A"/>
+                </a:solidFill>
+                <a:latin typeface="Consolas" pitchFamily="34" charset="0"/>
+                <a:ea typeface="Calibri" pitchFamily="34" charset="-122"/>
+                <a:cs typeface="Calibri" pitchFamily="34" charset="-120"/>
+              </a:rPr>
+              <a:t>        8.591.418.141 bytes</a:t>
+            </a:r>
+          </a:p>
+          <a:p>
+            <a:pPr algn="l" indent="0" marL="0">
+              <a:buNone/>
+            </a:pPr>
+            <a:r>
+              <a:rPr lang="en-US" sz="1050" dirty="0" b="0">
+                <a:solidFill>
+                  <a:srgbClr val="5B6B7A"/>
+                </a:solidFill>
+                <a:latin typeface="Consolas" pitchFamily="34" charset="0"/>
+                <a:ea typeface="Calibri" pitchFamily="34" charset="-122"/>
+                <a:cs typeface="Calibri" pitchFamily="34" charset="-120"/>
+              </a:rPr>
+              <a:t>      manifest.json</a:t>
+            </a:r>
+          </a:p>
+          <a:p>
+            <a:pPr algn="l" indent="0" marL="0">
+              <a:buNone/>
+            </a:pPr>
+            <a:r>
+              <a:rPr lang="en-US" sz="1050" dirty="0" b="0">
                 <a:solidFill>
                   <a:srgbClr val="5B6B7A"/>
                 </a:solidFill>
@@ -5487,111 +4192,15 @@
               <a:buNone/>
             </a:pPr>
             <a:r>
-              <a:rPr lang="en-US" sz="1100" dirty="0" b="0">
-                <a:solidFill>
-                  <a:srgbClr val="5B6B7A"/>
-                </a:solidFill>
-                <a:latin typeface="Consolas" pitchFamily="34" charset="0"/>
-                <a:ea typeface="Calibri" pitchFamily="34" charset="-122"/>
-                <a:cs typeface="Calibri" pitchFamily="34" charset="-120"/>
-              </a:rPr>
-              <a:t>Path convention:</a:t>
-            </a:r>
-          </a:p>
-          <a:p>
-            <a:pPr algn="l" indent="0" marL="0">
-              <a:buNone/>
-            </a:pPr>
-            <a:r>
-              <a:rPr lang="en-US" sz="1100" dirty="0" b="0">
-                <a:solidFill>
-                  <a:srgbClr val="5B6B7A"/>
-                </a:solidFill>
-                <a:latin typeface="Consolas" pitchFamily="34" charset="0"/>
-                <a:ea typeface="Calibri" pitchFamily="34" charset="-122"/>
-                <a:cs typeface="Calibri" pitchFamily="34" charset="-120"/>
-              </a:rPr>
-              <a:t>  data/raw/&lt;dataset&gt;/</a:t>
-            </a:r>
-          </a:p>
-          <a:p>
-            <a:pPr algn="l" indent="0" marL="0">
-              <a:buNone/>
-            </a:pPr>
-            <a:r>
-              <a:rPr lang="en-US" sz="1100" dirty="0" b="0">
-                <a:solidFill>
-                  <a:srgbClr val="5B6B7A"/>
-                </a:solidFill>
-                <a:latin typeface="Consolas" pitchFamily="34" charset="0"/>
-                <a:ea typeface="Calibri" pitchFamily="34" charset="-122"/>
-                <a:cs typeface="Calibri" pitchFamily="34" charset="-120"/>
-              </a:rPr>
-              <a:t>    ingest_date=YYYY-MM-DD/run_&lt;UTC&gt;/</a:t>
-            </a:r>
-          </a:p>
-          <a:p>
-            <a:pPr algn="l" indent="0" marL="0">
-              <a:buNone/>
-            </a:pPr>
-            <a:r>
-              <a:rPr lang="en-US" sz="1100" dirty="0" b="0">
-                <a:solidFill>
-                  <a:srgbClr val="5B6B7A"/>
-                </a:solidFill>
-                <a:latin typeface="Consolas" pitchFamily="34" charset="0"/>
-                <a:ea typeface="Calibri" pitchFamily="34" charset="-122"/>
-                <a:cs typeface="Calibri" pitchFamily="34" charset="-120"/>
-              </a:rPr>
-              <a:t/>
-            </a:r>
-          </a:p>
-          <a:p>
-            <a:pPr algn="l" indent="0" marL="0">
-              <a:buNone/>
-            </a:pPr>
-            <a:r>
-              <a:rPr lang="en-US" sz="1100" dirty="0" b="0">
-                <a:solidFill>
-                  <a:srgbClr val="5B6B7A"/>
-                </a:solidFill>
-                <a:latin typeface="Consolas" pitchFamily="34" charset="0"/>
-                <a:ea typeface="Calibri" pitchFamily="34" charset="-122"/>
-                <a:cs typeface="Calibri" pitchFamily="34" charset="-120"/>
-              </a:rPr>
-              <a:t>Raw file: không rỗng, giữ nguyên 100% bản gốc</a:t>
-            </a:r>
-          </a:p>
-          <a:p>
-            <a:pPr algn="l" indent="0" marL="0">
-              <a:buNone/>
-            </a:pPr>
-            <a:r>
-              <a:rPr lang="en-US" sz="1100" dirty="0" b="0">
-                <a:solidFill>
-                  <a:srgbClr val="5B6B7A"/>
-                </a:solidFill>
-                <a:latin typeface="Consolas" pitchFamily="34" charset="0"/>
-                <a:ea typeface="Calibri" pitchFamily="34" charset="-122"/>
-                <a:cs typeface="Calibri" pitchFamily="34" charset="-120"/>
-              </a:rPr>
-              <a:t>(không sửa 1 byte so với nguồn tải về).</a:t>
-            </a:r>
-          </a:p>
-          <a:p>
-            <a:pPr algn="l" indent="0" marL="0">
-              <a:buNone/>
-            </a:pPr>
-            <a:r>
-              <a:rPr lang="en-US" sz="1100" dirty="0" b="0">
-                <a:solidFill>
-                  <a:srgbClr val="5B6B7A"/>
-                </a:solidFill>
-                <a:latin typeface="Consolas" pitchFamily="34" charset="0"/>
-                <a:ea typeface="Calibri" pitchFamily="34" charset="-122"/>
-                <a:cs typeface="Calibri" pitchFamily="34" charset="-120"/>
-              </a:rPr>
-              <a:t>Đã kiểm: size + SHA-256 khớp manifest.</a:t>
+              <a:rPr lang="en-US" sz="1050" dirty="0" b="0">
+                <a:solidFill>
+                  <a:srgbClr val="5B6B7A"/>
+                </a:solidFill>
+                <a:latin typeface="Consolas" pitchFamily="34" charset="0"/>
+                <a:ea typeface="Calibri" pitchFamily="34" charset="-122"/>
+                <a:cs typeface="Calibri" pitchFamily="34" charset="-120"/>
+              </a:rPr>
+              <a:t>Không sửa 1 byte · size + SHA-256 khớp manifest</a:t>
             </a:r>
           </a:p>
         </p:txBody>
@@ -5604,8 +4213,8 @@
         </p:nvSpPr>
         <p:spPr>
           <a:xfrm>
-            <a:off x="6263640" y="1828800"/>
-            <a:ext cx="5074920" cy="4526280"/>
+            <a:off x="6263640" y="1783080"/>
+            <a:ext cx="5074920" cy="4572000"/>
           </a:xfrm>
           <a:prstGeom prst="roundRect">
             <a:avLst>
@@ -5631,7 +4240,7 @@
         </p:nvSpPr>
         <p:spPr>
           <a:xfrm>
-            <a:off x="6519672" y="1956816"/>
+            <a:off x="6519672" y="1911096"/>
             <a:ext cx="4562856" cy="310896"/>
           </a:xfrm>
           <a:prstGeom prst="rect">
@@ -5672,8 +4281,8 @@
         </p:nvSpPr>
         <p:spPr>
           <a:xfrm>
-            <a:off x="6519672" y="2811289"/>
-            <a:ext cx="4562856" cy="2945351"/>
+            <a:off x="6519672" y="2331720"/>
+            <a:ext cx="4562856" cy="1984568"/>
           </a:xfrm>
           <a:prstGeom prst="rect">
             <a:avLst/>
@@ -5691,15 +4300,15 @@
               <a:buNone/>
             </a:pPr>
             <a:r>
-              <a:rPr lang="en-US" sz="1100" dirty="0" b="0">
-                <a:solidFill>
-                  <a:srgbClr val="5B6B7A"/>
-                </a:solidFill>
-                <a:latin typeface="Consolas" pitchFamily="34" charset="0"/>
-                <a:ea typeface="Calibri" pitchFamily="34" charset="-122"/>
-                <a:cs typeface="Calibri" pitchFamily="34" charset="-120"/>
-              </a:rPr>
-              <a:t>manifest.json (đặt cạnh raw file):</a:t>
+              <a:rPr lang="en-US" sz="1050" dirty="0" b="0">
+                <a:solidFill>
+                  <a:srgbClr val="5B6B7A"/>
+                </a:solidFill>
+                <a:latin typeface="Consolas" pitchFamily="34" charset="0"/>
+                <a:ea typeface="Calibri" pitchFamily="34" charset="-122"/>
+                <a:cs typeface="Calibri" pitchFamily="34" charset="-120"/>
+              </a:rPr>
+              <a:t>dataset     : youtube_trending</a:t>
             </a:r>
             <a:endParaRPr lang="en-US" sz="1300" dirty="0"/>
           </a:p>
@@ -5708,183 +4317,135 @@
               <a:buNone/>
             </a:pPr>
             <a:r>
-              <a:rPr lang="en-US" sz="1100" dirty="0" b="0">
-                <a:solidFill>
-                  <a:srgbClr val="5B6B7A"/>
-                </a:solidFill>
-                <a:latin typeface="Consolas" pitchFamily="34" charset="0"/>
-                <a:ea typeface="Calibri" pitchFamily="34" charset="-122"/>
-                <a:cs typeface="Calibri" pitchFamily="34" charset="-120"/>
-              </a:rPr>
-              <a:t>  dataset      : youtube_trending</a:t>
-            </a:r>
-          </a:p>
-          <a:p>
-            <a:pPr algn="l" indent="0" marL="0">
-              <a:buNone/>
-            </a:pPr>
-            <a:r>
-              <a:rPr lang="en-US" sz="1100" dirty="0" b="0">
-                <a:solidFill>
-                  <a:srgbClr val="5B6B7A"/>
-                </a:solidFill>
-                <a:latin typeface="Consolas" pitchFamily="34" charset="0"/>
-                <a:ea typeface="Calibri" pitchFamily="34" charset="-122"/>
-                <a:cs typeface="Calibri" pitchFamily="34" charset="-120"/>
-              </a:rPr>
-              <a:t>  source       : trending_yt_videos_113_</a:t>
-            </a:r>
-          </a:p>
-          <a:p>
-            <a:pPr algn="l" indent="0" marL="0">
-              <a:buNone/>
-            </a:pPr>
-            <a:r>
-              <a:rPr lang="en-US" sz="1100" dirty="0" b="0">
-                <a:solidFill>
-                  <a:srgbClr val="5B6B7A"/>
-                </a:solidFill>
-                <a:latin typeface="Consolas" pitchFamily="34" charset="0"/>
-                <a:ea typeface="Calibri" pitchFamily="34" charset="-122"/>
-                <a:cs typeface="Calibri" pitchFamily="34" charset="-120"/>
-              </a:rPr>
-              <a:t>                 countries.csv</a:t>
-            </a:r>
-          </a:p>
-          <a:p>
-            <a:pPr algn="l" indent="0" marL="0">
-              <a:buNone/>
-            </a:pPr>
-            <a:r>
-              <a:rPr lang="en-US" sz="1100" dirty="0" b="0">
-                <a:solidFill>
-                  <a:srgbClr val="5B6B7A"/>
-                </a:solidFill>
-                <a:latin typeface="Consolas" pitchFamily="34" charset="0"/>
-                <a:ea typeface="Calibri" pitchFamily="34" charset="-122"/>
-                <a:cs typeface="Calibri" pitchFamily="34" charset="-120"/>
-              </a:rPr>
-              <a:t>  ingested_at  : 2026-10-20T14:30:13+00:00</a:t>
-            </a:r>
-          </a:p>
-          <a:p>
-            <a:pPr algn="l" indent="0" marL="0">
-              <a:buNone/>
-            </a:pPr>
-            <a:r>
-              <a:rPr lang="en-US" sz="1100" dirty="0" b="0">
-                <a:solidFill>
-                  <a:srgbClr val="5B6B7A"/>
-                </a:solidFill>
-                <a:latin typeface="Consolas" pitchFamily="34" charset="0"/>
-                <a:ea typeface="Calibri" pitchFamily="34" charset="-122"/>
-                <a:cs typeface="Calibri" pitchFamily="34" charset="-120"/>
-              </a:rPr>
-              <a:t>  bytes        : 8591418141</a:t>
-            </a:r>
-          </a:p>
-          <a:p>
-            <a:pPr algn="l" indent="0" marL="0">
-              <a:buNone/>
-            </a:pPr>
-            <a:r>
-              <a:rPr lang="en-US" sz="1100" dirty="0" b="0">
-                <a:solidFill>
-                  <a:srgbClr val="5B6B7A"/>
-                </a:solidFill>
-                <a:latin typeface="Consolas" pitchFamily="34" charset="0"/>
-                <a:ea typeface="Calibri" pitchFamily="34" charset="-122"/>
-                <a:cs typeface="Calibri" pitchFamily="34" charset="-120"/>
-              </a:rPr>
-              <a:t>  sha256       : 4310930bd2d1… (64 ký tự)</a:t>
-            </a:r>
-          </a:p>
-          <a:p>
-            <a:pPr algn="l" indent="0" marL="0">
-              <a:buNone/>
-            </a:pPr>
-            <a:r>
-              <a:rPr lang="en-US" sz="1100" dirty="0" b="0">
-                <a:solidFill>
-                  <a:srgbClr val="5B6B7A"/>
-                </a:solidFill>
-                <a:latin typeface="Consolas" pitchFamily="34" charset="0"/>
-                <a:ea typeface="Calibri" pitchFamily="34" charset="-122"/>
-                <a:cs typeface="Calibri" pitchFamily="34" charset="-120"/>
-              </a:rPr>
-              <a:t>  destination  : data/raw/…/run_…/</a:t>
-            </a:r>
-          </a:p>
-          <a:p>
-            <a:pPr algn="l" indent="0" marL="0">
-              <a:buNone/>
-            </a:pPr>
-            <a:r>
-              <a:rPr lang="en-US" sz="1100" dirty="0" b="0">
-                <a:solidFill>
-                  <a:srgbClr val="5B6B7A"/>
-                </a:solidFill>
-                <a:latin typeface="Consolas" pitchFamily="34" charset="0"/>
-                <a:ea typeface="Calibri" pitchFamily="34" charset="-122"/>
-                <a:cs typeface="Calibri" pitchFamily="34" charset="-120"/>
-              </a:rPr>
-              <a:t>  records      : 6094047  (RFC4180)</a:t>
-            </a:r>
-          </a:p>
-          <a:p>
-            <a:pPr algn="l" indent="0" marL="0">
-              <a:buNone/>
-            </a:pPr>
-            <a:r>
-              <a:rPr lang="en-US" sz="1100" dirty="0" b="0">
-                <a:solidFill>
-                  <a:srgbClr val="5B6B7A"/>
-                </a:solidFill>
-                <a:latin typeface="Consolas" pitchFamily="34" charset="0"/>
-                <a:ea typeface="Calibri" pitchFamily="34" charset="-122"/>
-                <a:cs typeface="Calibri" pitchFamily="34" charset="-120"/>
-              </a:rPr>
-              <a:t>  status       : success</a:t>
-            </a:r>
-          </a:p>
-          <a:p>
-            <a:pPr algn="l" indent="0" marL="0">
-              <a:buNone/>
-            </a:pPr>
-            <a:r>
-              <a:rPr lang="en-US" sz="1100" dirty="0" b="0">
-                <a:solidFill>
-                  <a:srgbClr val="5B6B7A"/>
-                </a:solidFill>
-                <a:latin typeface="Consolas" pitchFamily="34" charset="0"/>
-                <a:ea typeface="Calibri" pitchFamily="34" charset="-122"/>
-                <a:cs typeface="Calibri" pitchFamily="34" charset="-120"/>
-              </a:rPr>
-              <a:t>  amendments[] : 1 mục (mọi sửa metadata</a:t>
-            </a:r>
-          </a:p>
-          <a:p>
-            <a:pPr algn="l" indent="0" marL="0">
-              <a:buNone/>
-            </a:pPr>
-            <a:r>
-              <a:rPr lang="en-US" sz="1100" dirty="0" b="0">
-                <a:solidFill>
-                  <a:srgbClr val="5B6B7A"/>
-                </a:solidFill>
-                <a:latin typeface="Consolas" pitchFamily="34" charset="0"/>
-                <a:ea typeface="Calibri" pitchFamily="34" charset="-122"/>
-                <a:cs typeface="Calibri" pitchFamily="34" charset="-120"/>
-              </a:rPr>
-              <a:t>                 đều ghi lại kèm thời điểm)</a:t>
-            </a:r>
-          </a:p>
-          <a:p>
-            <a:pPr algn="l" indent="0" marL="0">
-              <a:buNone/>
-            </a:pPr>
-            <a:r>
-              <a:rPr lang="en-US" sz="1100" dirty="0" b="0">
+              <a:rPr lang="en-US" sz="1050" dirty="0" b="0">
+                <a:solidFill>
+                  <a:srgbClr val="5B6B7A"/>
+                </a:solidFill>
+                <a:latin typeface="Consolas" pitchFamily="34" charset="0"/>
+                <a:ea typeface="Calibri" pitchFamily="34" charset="-122"/>
+                <a:cs typeface="Calibri" pitchFamily="34" charset="-120"/>
+              </a:rPr>
+              <a:t>source      : …/trending_yt_videos_113_countries.csv</a:t>
+            </a:r>
+          </a:p>
+          <a:p>
+            <a:pPr algn="l" indent="0" marL="0">
+              <a:buNone/>
+            </a:pPr>
+            <a:r>
+              <a:rPr lang="en-US" sz="1050" dirty="0" b="0">
+                <a:solidFill>
+                  <a:srgbClr val="5B6B7A"/>
+                </a:solidFill>
+                <a:latin typeface="Consolas" pitchFamily="34" charset="0"/>
+                <a:ea typeface="Calibri" pitchFamily="34" charset="-122"/>
+                <a:cs typeface="Calibri" pitchFamily="34" charset="-120"/>
+              </a:rPr>
+              <a:t>ingested_at : 2026-10-20T14:30:13+00:00</a:t>
+            </a:r>
+          </a:p>
+          <a:p>
+            <a:pPr algn="l" indent="0" marL="0">
+              <a:buNone/>
+            </a:pPr>
+            <a:r>
+              <a:rPr lang="en-US" sz="1050" dirty="0" b="0">
+                <a:solidFill>
+                  <a:srgbClr val="5B6B7A"/>
+                </a:solidFill>
+                <a:latin typeface="Consolas" pitchFamily="34" charset="0"/>
+                <a:ea typeface="Calibri" pitchFamily="34" charset="-122"/>
+                <a:cs typeface="Calibri" pitchFamily="34" charset="-120"/>
+              </a:rPr>
+              <a:t>bytes       : 8591418141</a:t>
+            </a:r>
+          </a:p>
+          <a:p>
+            <a:pPr algn="l" indent="0" marL="0">
+              <a:buNone/>
+            </a:pPr>
+            <a:r>
+              <a:rPr lang="en-US" sz="1050" dirty="0" b="0">
+                <a:solidFill>
+                  <a:srgbClr val="5B6B7A"/>
+                </a:solidFill>
+                <a:latin typeface="Consolas" pitchFamily="34" charset="0"/>
+                <a:ea typeface="Calibri" pitchFamily="34" charset="-122"/>
+                <a:cs typeface="Calibri" pitchFamily="34" charset="-120"/>
+              </a:rPr>
+              <a:t>sha256      : 4310930bd2d1… (64 ký tự)</a:t>
+            </a:r>
+          </a:p>
+          <a:p>
+            <a:pPr algn="l" indent="0" marL="0">
+              <a:buNone/>
+            </a:pPr>
+            <a:r>
+              <a:rPr lang="en-US" sz="1050" dirty="0" b="0">
+                <a:solidFill>
+                  <a:srgbClr val="5B6B7A"/>
+                </a:solidFill>
+                <a:latin typeface="Consolas" pitchFamily="34" charset="0"/>
+                <a:ea typeface="Calibri" pitchFamily="34" charset="-122"/>
+                <a:cs typeface="Calibri" pitchFamily="34" charset="-120"/>
+              </a:rPr>
+              <a:t>destination : data/raw/…/run_…/</a:t>
+            </a:r>
+          </a:p>
+          <a:p>
+            <a:pPr algn="l" indent="0" marL="0">
+              <a:buNone/>
+            </a:pPr>
+            <a:r>
+              <a:rPr lang="en-US" sz="1050" dirty="0" b="0">
+                <a:solidFill>
+                  <a:srgbClr val="5B6B7A"/>
+                </a:solidFill>
+                <a:latin typeface="Consolas" pitchFamily="34" charset="0"/>
+                <a:ea typeface="Calibri" pitchFamily="34" charset="-122"/>
+                <a:cs typeface="Calibri" pitchFamily="34" charset="-120"/>
+              </a:rPr>
+              <a:t>records     : 6094047 (RFC4180)</a:t>
+            </a:r>
+          </a:p>
+          <a:p>
+            <a:pPr algn="l" indent="0" marL="0">
+              <a:buNone/>
+            </a:pPr>
+            <a:r>
+              <a:rPr lang="en-US" sz="1050" dirty="0" b="0">
+                <a:solidFill>
+                  <a:srgbClr val="5B6B7A"/>
+                </a:solidFill>
+                <a:latin typeface="Consolas" pitchFamily="34" charset="0"/>
+                <a:ea typeface="Calibri" pitchFamily="34" charset="-122"/>
+                <a:cs typeface="Calibri" pitchFamily="34" charset="-120"/>
+              </a:rPr>
+              <a:t>status      : success</a:t>
+            </a:r>
+          </a:p>
+          <a:p>
+            <a:pPr algn="l" indent="0" marL="0">
+              <a:buNone/>
+            </a:pPr>
+            <a:r>
+              <a:rPr lang="en-US" sz="1050" dirty="0" b="0">
+                <a:solidFill>
+                  <a:srgbClr val="5B6B7A"/>
+                </a:solidFill>
+                <a:latin typeface="Consolas" pitchFamily="34" charset="0"/>
+                <a:ea typeface="Calibri" pitchFamily="34" charset="-122"/>
+                <a:cs typeface="Calibri" pitchFamily="34" charset="-120"/>
+              </a:rPr>
+              <a:t>amendments  : 1 mục (audit trail)</a:t>
+            </a:r>
+          </a:p>
+          <a:p>
+            <a:pPr algn="l" indent="0" marL="0">
+              <a:buNone/>
+            </a:pPr>
+            <a:r>
+              <a:rPr lang="en-US" sz="1050" dirty="0" b="0">
                 <a:solidFill>
                   <a:srgbClr val="5B6B7A"/>
                 </a:solidFill>
@@ -5900,63 +4461,31 @@
               <a:buNone/>
             </a:pPr>
             <a:r>
-              <a:rPr lang="en-US" sz="1100" dirty="0" b="0">
-                <a:solidFill>
-                  <a:srgbClr val="5B6B7A"/>
-                </a:solidFill>
-                <a:latin typeface="Consolas" pitchFamily="34" charset="0"/>
-                <a:ea typeface="Calibri" pitchFamily="34" charset="-122"/>
-                <a:cs typeface="Calibri" pitchFamily="34" charset="-120"/>
-              </a:rPr>
-              <a:t>Log evidence:</a:t>
-            </a:r>
-          </a:p>
-          <a:p>
-            <a:pPr algn="l" indent="0" marL="0">
-              <a:buNone/>
-            </a:pPr>
-            <a:r>
-              <a:rPr lang="en-US" sz="1100" dirty="0" b="0">
-                <a:solidFill>
-                  <a:srgbClr val="5B6B7A"/>
-                </a:solidFill>
-                <a:latin typeface="Consolas" pitchFamily="34" charset="0"/>
-                <a:ea typeface="Calibri" pitchFamily="34" charset="-122"/>
-                <a:cs typeface="Calibri" pitchFamily="34" charset="-120"/>
-              </a:rPr>
-              <a:t>  logs/env_check.txt   → PASS</a:t>
-            </a:r>
-          </a:p>
-          <a:p>
-            <a:pPr algn="l" indent="0" marL="0">
-              <a:buNone/>
-            </a:pPr>
-            <a:r>
-              <a:rPr lang="en-US" sz="1100" dirty="0" b="0">
-                <a:solidFill>
-                  <a:srgbClr val="5B6B7A"/>
-                </a:solidFill>
-                <a:latin typeface="Consolas" pitchFamily="34" charset="0"/>
-                <a:ea typeface="Calibri" pitchFamily="34" charset="-122"/>
-                <a:cs typeface="Calibri" pitchFamily="34" charset="-120"/>
-              </a:rPr>
-              <a:t>  logs/ingest.log      → success + skip</a:t>
-            </a:r>
-          </a:p>
-          <a:p>
-            <a:pPr algn="l" indent="0" marL="0">
-              <a:buNone/>
-            </a:pPr>
-            <a:r>
-              <a:rPr lang="en-US" sz="1100" dirty="0" b="0">
-                <a:solidFill>
-                  <a:srgbClr val="5B6B7A"/>
-                </a:solidFill>
-                <a:latin typeface="Consolas" pitchFamily="34" charset="0"/>
-                <a:ea typeface="Calibri" pitchFamily="34" charset="-122"/>
-                <a:cs typeface="Calibri" pitchFamily="34" charset="-120"/>
-              </a:rPr>
-              <a:t>  logs/transform.log   → Spark 6.074.658 dòng</a:t>
+              <a:rPr lang="en-US" sz="1050" dirty="0" b="0">
+                <a:solidFill>
+                  <a:srgbClr val="5B6B7A"/>
+                </a:solidFill>
+                <a:latin typeface="Consolas" pitchFamily="34" charset="0"/>
+                <a:ea typeface="Calibri" pitchFamily="34" charset="-122"/>
+                <a:cs typeface="Calibri" pitchFamily="34" charset="-120"/>
+              </a:rPr>
+              <a:t>logs/env_check.txt   → PASS</a:t>
+            </a:r>
+          </a:p>
+          <a:p>
+            <a:pPr algn="l" indent="0" marL="0">
+              <a:buNone/>
+            </a:pPr>
+            <a:r>
+              <a:rPr lang="en-US" sz="1050" dirty="0" b="0">
+                <a:solidFill>
+                  <a:srgbClr val="5B6B7A"/>
+                </a:solidFill>
+                <a:latin typeface="Consolas" pitchFamily="34" charset="0"/>
+                <a:ea typeface="Calibri" pitchFamily="34" charset="-122"/>
+                <a:cs typeface="Calibri" pitchFamily="34" charset="-120"/>
+              </a:rPr>
+              <a:t>logs/ingest.log      → success + duplicate_skip</a:t>
             </a:r>
           </a:p>
         </p:txBody>
@@ -6070,55 +4599,14 @@
       </p:sp>
       <p:sp>
         <p:nvSpPr>
-          <p:cNvPr id="4" name="Text 2"/>
-          <p:cNvSpPr/>
-          <p:nvPr/>
-        </p:nvSpPr>
-        <p:spPr>
-          <a:xfrm>
-            <a:off x="594360" y="1261872"/>
-            <a:ext cx="10972800" cy="310896"/>
-          </a:xfrm>
-          <a:prstGeom prst="rect">
-            <a:avLst/>
-          </a:prstGeom>
-          <a:noFill/>
-          <a:ln/>
-        </p:spPr>
-        <p:txBody>
-          <a:bodyPr wrap="square" lIns="0" tIns="0" rIns="0" bIns="0" rtlCol="0" anchor="ctr">
-            <a:normAutofit/>
-          </a:bodyPr>
-          <a:lstStyle/>
-          <a:p>
-            <a:pPr algn="l" indent="0" marL="0">
-              <a:buNone/>
-            </a:pPr>
-            <a:r>
-              <a:rPr lang="en-US" sz="1400" dirty="0">
-                <a:solidFill>
-                  <a:srgbClr val="5B6B7A"/>
-                </a:solidFill>
-                <a:latin typeface="Calibri" pitchFamily="34" charset="0"/>
-                <a:ea typeface="Calibri" pitchFamily="34" charset="-122"/>
-                <a:cs typeface="Calibri" pitchFamily="34" charset="-120"/>
-              </a:rPr>
-              <a:t>Kết thúc bằng quyết định kỹ thuật rõ ràng.</a:t>
-            </a:r>
-            <a:endParaRPr lang="en-US" sz="1400" dirty="0"/>
-          </a:p>
-        </p:txBody>
-      </p:sp>
-      <p:sp>
-        <p:nvSpPr>
           <p:cNvPr id="5" name="Shape 3"/>
           <p:cNvSpPr/>
           <p:nvPr/>
         </p:nvSpPr>
         <p:spPr>
           <a:xfrm>
-            <a:off x="777240" y="1828800"/>
-            <a:ext cx="5074920" cy="2069493"/>
+            <a:off x="777240" y="1783080"/>
+            <a:ext cx="5074920" cy="2194560"/>
           </a:xfrm>
           <a:prstGeom prst="roundRect">
             <a:avLst>
@@ -6144,7 +4632,7 @@
         </p:nvSpPr>
         <p:spPr>
           <a:xfrm>
-            <a:off x="1033272" y="1956816"/>
+            <a:off x="1033272" y="1911096"/>
             <a:ext cx="4562856" cy="310896"/>
           </a:xfrm>
           <a:prstGeom prst="rect">
@@ -6171,7 +4659,7 @@
                 <a:ea typeface="Calibri" pitchFamily="34" charset="-122"/>
                 <a:cs typeface="Calibri" pitchFamily="34" charset="-120"/>
               </a:rPr>
-              <a:t>NẾU CHẠY INGEST 3 LẦN</a:t>
+              <a:t>CHẠY INGEST 3 LẦN</a:t>
             </a:r>
             <a:endParaRPr lang="en-US" sz="1600" dirty="0"/>
           </a:p>
@@ -6185,8 +4673,8 @@
         </p:nvSpPr>
         <p:spPr>
           <a:xfrm>
-            <a:off x="1033272" y="2642119"/>
-            <a:ext cx="4562856" cy="826903"/>
+            <a:off x="1033272" y="2331720"/>
+            <a:ext cx="4562856" cy="945032"/>
           </a:xfrm>
           <a:prstGeom prst="rect">
             <a:avLst/>
@@ -6204,15 +4692,15 @@
               <a:buNone/>
             </a:pPr>
             <a:r>
-              <a:rPr lang="en-US" sz="1050" dirty="0" b="0">
-                <a:solidFill>
-                  <a:srgbClr val="5B6B7A"/>
-                </a:solidFill>
-                <a:latin typeface="Consolas" pitchFamily="34" charset="0"/>
-                <a:ea typeface="Calibri" pitchFamily="34" charset="-122"/>
-                <a:cs typeface="Calibri" pitchFamily="34" charset="-120"/>
-              </a:rPr>
-              <a:t>skip (mặc định): hash trùng → SKIP</a:t>
+              <a:rPr lang="en-US" sz="1000" dirty="0" b="0">
+                <a:solidFill>
+                  <a:srgbClr val="5B6B7A"/>
+                </a:solidFill>
+                <a:latin typeface="Consolas" pitchFamily="34" charset="0"/>
+                <a:ea typeface="Calibri" pitchFamily="34" charset="-122"/>
+                <a:cs typeface="Calibri" pitchFamily="34" charset="-120"/>
+              </a:rPr>
+              <a:t>lần 1: tạo run + copy + manifest</a:t>
             </a:r>
             <a:endParaRPr lang="en-US" sz="1300" dirty="0"/>
           </a:p>
@@ -6221,63 +4709,79 @@
               <a:buNone/>
             </a:pPr>
             <a:r>
-              <a:rPr lang="en-US" sz="1050" dirty="0" b="0">
-                <a:solidFill>
-                  <a:srgbClr val="5B6B7A"/>
-                </a:solidFill>
-                <a:latin typeface="Consolas" pitchFamily="34" charset="0"/>
-                <a:ea typeface="Calibri" pitchFamily="34" charset="-122"/>
-                <a:cs typeface="Calibri" pitchFamily="34" charset="-120"/>
-              </a:rPr>
-              <a:t>  lần 2, 3 → duplicate_skip, raw không đổi</a:t>
-            </a:r>
-          </a:p>
-          <a:p>
-            <a:pPr algn="l" indent="0" marL="0">
-              <a:buNone/>
-            </a:pPr>
-            <a:r>
-              <a:rPr lang="en-US" sz="1050" dirty="0" b="0">
-                <a:solidFill>
-                  <a:srgbClr val="5B6B7A"/>
-                </a:solidFill>
-                <a:latin typeface="Consolas" pitchFamily="34" charset="0"/>
-                <a:ea typeface="Calibri" pitchFamily="34" charset="-122"/>
-                <a:cs typeface="Calibri" pitchFamily="34" charset="-120"/>
-              </a:rPr>
-              <a:t>new-run: hash trùng vẫn tạo run_id mới</a:t>
-            </a:r>
-          </a:p>
-          <a:p>
-            <a:pPr algn="l" indent="0" marL="0">
-              <a:buNone/>
-            </a:pPr>
-            <a:r>
-              <a:rPr lang="en-US" sz="1050" dirty="0" b="0">
-                <a:solidFill>
-                  <a:srgbClr val="5B6B7A"/>
-                </a:solidFill>
-                <a:latin typeface="Consolas" pitchFamily="34" charset="0"/>
-                <a:ea typeface="Calibri" pitchFamily="34" charset="-122"/>
-                <a:cs typeface="Calibri" pitchFamily="34" charset="-120"/>
-              </a:rPr>
-              <a:t>fail: hash trùng → exit 1</a:t>
-            </a:r>
-          </a:p>
-          <a:p>
-            <a:pPr algn="l" indent="0" marL="0">
-              <a:buNone/>
-            </a:pPr>
-            <a:r>
-              <a:rPr lang="en-US" sz="1050" dirty="0" b="0">
-                <a:solidFill>
-                  <a:srgbClr val="5B6B7A"/>
-                </a:solidFill>
-                <a:latin typeface="Consolas" pitchFamily="34" charset="0"/>
-                <a:ea typeface="Calibri" pitchFamily="34" charset="-122"/>
-                <a:cs typeface="Calibri" pitchFamily="34" charset="-120"/>
-              </a:rPr>
-              <a:t>hash khác → luôn tạo run mới (append)</a:t>
+              <a:rPr lang="en-US" sz="1000" dirty="0" b="0">
+                <a:solidFill>
+                  <a:srgbClr val="5B6B7A"/>
+                </a:solidFill>
+                <a:latin typeface="Consolas" pitchFamily="34" charset="0"/>
+                <a:ea typeface="Calibri" pitchFamily="34" charset="-122"/>
+                <a:cs typeface="Calibri" pitchFamily="34" charset="-120"/>
+              </a:rPr>
+              <a:t>lần 2–3: hash trùng → SKIP</a:t>
+            </a:r>
+          </a:p>
+          <a:p>
+            <a:pPr algn="l" indent="0" marL="0">
+              <a:buNone/>
+            </a:pPr>
+            <a:r>
+              <a:rPr lang="en-US" sz="1000" dirty="0" b="0">
+                <a:solidFill>
+                  <a:srgbClr val="5B6B7A"/>
+                </a:solidFill>
+                <a:latin typeface="Consolas" pitchFamily="34" charset="0"/>
+                <a:ea typeface="Calibri" pitchFamily="34" charset="-122"/>
+                <a:cs typeface="Calibri" pitchFamily="34" charset="-120"/>
+              </a:rPr>
+              <a:t>→ raw giữ nguyên, đúng 1 run</a:t>
+            </a:r>
+          </a:p>
+          <a:p>
+            <a:pPr algn="l" indent="0" marL="0">
+              <a:buNone/>
+            </a:pPr>
+            <a:r>
+              <a:rPr lang="en-US" sz="1000" dirty="0" b="0">
+                <a:solidFill>
+                  <a:srgbClr val="5B6B7A"/>
+                </a:solidFill>
+                <a:latin typeface="Consolas" pitchFamily="34" charset="0"/>
+                <a:ea typeface="Calibri" pitchFamily="34" charset="-122"/>
+                <a:cs typeface="Calibri" pitchFamily="34" charset="-120"/>
+              </a:rPr>
+              <a:t/>
+            </a:r>
+          </a:p>
+          <a:p>
+            <a:pPr algn="l" indent="0" marL="0">
+              <a:buNone/>
+            </a:pPr>
+            <a:r>
+              <a:rPr lang="en-US" sz="1000" dirty="0" b="0">
+                <a:solidFill>
+                  <a:srgbClr val="5B6B7A"/>
+                </a:solidFill>
+                <a:latin typeface="Consolas" pitchFamily="34" charset="0"/>
+                <a:ea typeface="Calibri" pitchFamily="34" charset="-122"/>
+                <a:cs typeface="Calibri" pitchFamily="34" charset="-120"/>
+              </a:rPr>
+              <a:t>hash khác → run mới (append)</a:t>
+            </a:r>
+          </a:p>
+          <a:p>
+            <a:pPr algn="l" indent="0" marL="0">
+              <a:buNone/>
+            </a:pPr>
+            <a:r>
+              <a:rPr lang="en-US" sz="1000" dirty="0" b="0">
+                <a:solidFill>
+                  <a:srgbClr val="5B6B7A"/>
+                </a:solidFill>
+                <a:latin typeface="Consolas" pitchFamily="34" charset="0"/>
+                <a:ea typeface="Calibri" pitchFamily="34" charset="-122"/>
+                <a:cs typeface="Calibri" pitchFamily="34" charset="-120"/>
+              </a:rPr>
+              <a:t>gate fail → exit 1</a:t>
             </a:r>
           </a:p>
         </p:txBody>
@@ -6290,8 +4794,8 @@
         </p:nvSpPr>
         <p:spPr>
           <a:xfrm>
-            <a:off x="777240" y="4081173"/>
-            <a:ext cx="5074920" cy="1844139"/>
+            <a:off x="6263640" y="1783080"/>
+            <a:ext cx="5074920" cy="2194560"/>
           </a:xfrm>
           <a:prstGeom prst="roundRect">
             <a:avLst>
@@ -6317,7 +4821,7 @@
         </p:nvSpPr>
         <p:spPr>
           <a:xfrm>
-            <a:off x="1033272" y="4209189"/>
+            <a:off x="6519672" y="1911096"/>
             <a:ext cx="4562856" cy="310896"/>
           </a:xfrm>
           <a:prstGeom prst="rect">
@@ -6358,8 +4862,8 @@
         </p:nvSpPr>
         <p:spPr>
           <a:xfrm>
-            <a:off x="1033272" y="4677922"/>
-            <a:ext cx="4562856" cy="1034689"/>
+            <a:off x="6519672" y="2331720"/>
+            <a:ext cx="4562856" cy="517345"/>
           </a:xfrm>
           <a:prstGeom prst="rect">
             <a:avLst/>
@@ -6385,7 +4889,7 @@
                 <a:ea typeface="Calibri" pitchFamily="34" charset="-122"/>
                 <a:cs typeface="Calibri" pitchFamily="34" charset="-120"/>
               </a:rPr>
-              <a:t>Schema nguồn khác đề cương: thiếu category_id,</a:t>
+              <a:t>Schema nguồn thiếu category_id; description nhiều dòng → Spark đếm sai 17 lần.</a:t>
             </a:r>
             <a:endParaRPr lang="en-US" sz="1300" dirty="0"/>
           </a:p>
@@ -6402,7 +4906,7 @@
                 <a:ea typeface="Calibri" pitchFamily="34" charset="-122"/>
                 <a:cs typeface="Calibri" pitchFamily="34" charset="-120"/>
               </a:rPr>
-              <a:t>description nhiều dòng → xử lý bằng SRC_MAP +</a:t>
+              <a:t>Đã xử lý: SRC_MAP + split_csv.py + verify_raw_records.py.</a:t>
             </a:r>
           </a:p>
           <a:p>
@@ -6418,55 +4922,7 @@
                 <a:ea typeface="Calibri" pitchFamily="34" charset="-122"/>
                 <a:cs typeface="Calibri" pitchFamily="34" charset="-120"/>
               </a:rPr>
-              <a:t>split_csv.py (1 dòng = 1 record).</a:t>
-            </a:r>
-          </a:p>
-          <a:p>
-            <a:pPr algn="l" indent="0" marL="0">
-              <a:buNone/>
-            </a:pPr>
-            <a:r>
-              <a:rPr lang="en-US" sz="1050" dirty="0" b="0">
-                <a:solidFill>
-                  <a:srgbClr val="5B6B7A"/>
-                </a:solidFill>
-                <a:latin typeface="Calibri" pitchFamily="34" charset="0"/>
-                <a:ea typeface="Calibri" pitchFamily="34" charset="-122"/>
-                <a:cs typeface="Calibri" pitchFamily="34" charset="-120"/>
-              </a:rPr>
-              <a:t>Rủi ro còn lại: nguồn cập nhật hằng ngày.</a:t>
-            </a:r>
-          </a:p>
-          <a:p>
-            <a:pPr algn="l" indent="0" marL="0">
-              <a:buNone/>
-            </a:pPr>
-            <a:r>
-              <a:rPr lang="en-US" sz="1050" dirty="0" b="0">
-                <a:solidFill>
-                  <a:srgbClr val="5B6B7A"/>
-                </a:solidFill>
-                <a:latin typeface="Calibri" pitchFamily="34" charset="0"/>
-                <a:ea typeface="Calibri" pitchFamily="34" charset="-122"/>
-                <a:cs typeface="Calibri" pitchFamily="34" charset="-120"/>
-              </a:rPr>
-              <a:t>Owner: Phúc (transform) · Linh (Parquet/DuckDB)</a:t>
-            </a:r>
-          </a:p>
-          <a:p>
-            <a:pPr algn="l" indent="0" marL="0">
-              <a:buNone/>
-            </a:pPr>
-            <a:r>
-              <a:rPr lang="en-US" sz="1050" dirty="0" b="0">
-                <a:solidFill>
-                  <a:srgbClr val="5B6B7A"/>
-                </a:solidFill>
-                <a:latin typeface="Calibri" pitchFamily="34" charset="0"/>
-                <a:ea typeface="Calibri" pitchFamily="34" charset="-122"/>
-                <a:cs typeface="Calibri" pitchFamily="34" charset="-120"/>
-              </a:rPr>
-              <a:t>Deadline: trước Buổi 7</a:t>
+              <a:t>Owner: Phúc · deadline: trước Buổi 7.</a:t>
             </a:r>
           </a:p>
         </p:txBody>
@@ -6479,8 +4935,8 @@
         </p:nvSpPr>
         <p:spPr>
           <a:xfrm>
-            <a:off x="6263640" y="1828800"/>
-            <a:ext cx="5074920" cy="2069493"/>
+            <a:off x="777240" y="4160520"/>
+            <a:ext cx="5074920" cy="2194560"/>
           </a:xfrm>
           <a:prstGeom prst="roundRect">
             <a:avLst>
@@ -6506,7 +4962,7 @@
         </p:nvSpPr>
         <p:spPr>
           <a:xfrm>
-            <a:off x="6519672" y="1956816"/>
+            <a:off x="1033272" y="4288536"/>
             <a:ext cx="4562856" cy="310896"/>
           </a:xfrm>
           <a:prstGeom prst="rect">
@@ -6547,8 +5003,8 @@
         </p:nvSpPr>
         <p:spPr>
           <a:xfrm>
-            <a:off x="6519672" y="2425549"/>
-            <a:ext cx="4562856" cy="1260043"/>
+            <a:off x="1033272" y="4709160"/>
+            <a:ext cx="4562856" cy="945032"/>
           </a:xfrm>
           <a:prstGeom prst="rect">
             <a:avLst/>
@@ -6574,7 +5030,7 @@
                 <a:ea typeface="Calibri" pitchFamily="34" charset="-122"/>
                 <a:cs typeface="Calibri" pitchFamily="34" charset="-120"/>
               </a:rPr>
-              <a:t>Tag: checkpoint-2  (git log -1 checkpoint-2)</a:t>
+              <a:t>tag: checkpoint-2</a:t>
             </a:r>
             <a:endParaRPr lang="en-US" sz="1300" dirty="0"/>
           </a:p>
@@ -6591,7 +5047,7 @@
                 <a:ea typeface="Calibri" pitchFamily="34" charset="-122"/>
                 <a:cs typeface="Calibri" pitchFamily="34" charset="-120"/>
               </a:rPr>
-              <a:t>Manifest: data/raw/youtube_trending/</a:t>
+              <a:t>manifest: data/raw/…/run_…/manifest.json</a:t>
             </a:r>
           </a:p>
           <a:p>
@@ -6607,7 +5063,7 @@
                 <a:ea typeface="Calibri" pitchFamily="34" charset="-122"/>
                 <a:cs typeface="Calibri" pitchFamily="34" charset="-120"/>
               </a:rPr>
-              <a:t>  …/run_20261020T143013Z/manifest.json</a:t>
+              <a:t>logs/env_check.txt</a:t>
             </a:r>
           </a:p>
           <a:p>
@@ -6623,7 +5079,7 @@
                 <a:ea typeface="Calibri" pitchFamily="34" charset="-122"/>
                 <a:cs typeface="Calibri" pitchFamily="34" charset="-120"/>
               </a:rPr>
-              <a:t>Logs: logs/env_check.txt</a:t>
+              <a:t>logs/ingest.log</a:t>
             </a:r>
           </a:p>
           <a:p>
@@ -6639,7 +5095,7 @@
                 <a:ea typeface="Calibri" pitchFamily="34" charset="-122"/>
                 <a:cs typeface="Calibri" pitchFamily="34" charset="-120"/>
               </a:rPr>
-              <a:t>      logs/ingest.log</a:t>
+              <a:t>docs/Checkpoint2_Report_*.pptx</a:t>
             </a:r>
           </a:p>
           <a:p>
@@ -6655,39 +5111,7 @@
                 <a:ea typeface="Calibri" pitchFamily="34" charset="-122"/>
                 <a:cs typeface="Calibri" pitchFamily="34" charset="-120"/>
               </a:rPr>
-              <a:t>      logs/transform.log</a:t>
-            </a:r>
-          </a:p>
-          <a:p>
-            <a:pPr algn="l" indent="0" marL="0">
-              <a:buNone/>
-            </a:pPr>
-            <a:r>
-              <a:rPr lang="en-US" sz="1000" dirty="0" b="0">
-                <a:solidFill>
-                  <a:srgbClr val="5B6B7A"/>
-                </a:solidFill>
-                <a:latin typeface="Consolas" pitchFamily="34" charset="0"/>
-                <a:ea typeface="Calibri" pitchFamily="34" charset="-122"/>
-                <a:cs typeface="Calibri" pitchFamily="34" charset="-120"/>
-              </a:rPr>
-              <a:t>Reports: docs/Checkpoint2_Report_*.pptx</a:t>
-            </a:r>
-          </a:p>
-          <a:p>
-            <a:pPr algn="l" indent="0" marL="0">
-              <a:buNone/>
-            </a:pPr>
-            <a:r>
-              <a:rPr lang="en-US" sz="1000" dirty="0" b="0">
-                <a:solidFill>
-                  <a:srgbClr val="5B6B7A"/>
-                </a:solidFill>
-                <a:latin typeface="Consolas" pitchFamily="34" charset="0"/>
-                <a:ea typeface="Calibri" pitchFamily="34" charset="-122"/>
-                <a:cs typeface="Calibri" pitchFamily="34" charset="-120"/>
-              </a:rPr>
-              <a:t>         docs/Checkpoint2_Brief_Filled.docx</a:t>
+              <a:t>docs/Checkpoint2_Brief_Filled.docx</a:t>
             </a:r>
           </a:p>
         </p:txBody>
@@ -6700,8 +5124,8 @@
         </p:nvSpPr>
         <p:spPr>
           <a:xfrm>
-            <a:off x="6263640" y="4081173"/>
-            <a:ext cx="5074920" cy="1844139"/>
+            <a:off x="6263640" y="4160520"/>
+            <a:ext cx="5074920" cy="2194560"/>
           </a:xfrm>
           <a:prstGeom prst="roundRect">
             <a:avLst>
@@ -6727,7 +5151,7 @@
         </p:nvSpPr>
         <p:spPr>
           <a:xfrm>
-            <a:off x="6519672" y="4209189"/>
+            <a:off x="6519672" y="4288536"/>
             <a:ext cx="4562856" cy="310896"/>
           </a:xfrm>
           <a:prstGeom prst="rect">
@@ -6768,8 +5192,8 @@
         </p:nvSpPr>
         <p:spPr>
           <a:xfrm>
-            <a:off x="6519672" y="4833946"/>
-            <a:ext cx="4562856" cy="722640"/>
+            <a:off x="6519672" y="4709160"/>
+            <a:ext cx="4562856" cy="361320"/>
           </a:xfrm>
           <a:prstGeom prst="rect">
             <a:avLst/>
@@ -6795,7 +5219,7 @@
                 <a:ea typeface="Calibri" pitchFamily="34" charset="-122"/>
                 <a:cs typeface="Calibri" pitchFamily="34" charset="-120"/>
               </a:rPr>
-              <a:t>1) Ingest snapshot mới (dữ liệu cập nhật hằng</a:t>
+              <a:t>1) Ingest snapshot mới để so sánh growth 2 kỳ.</a:t>
             </a:r>
             <a:endParaRPr lang="en-US" sz="1300" dirty="0"/>
           </a:p>
@@ -6812,81 +5236,8 @@
                 <a:ea typeface="Calibri" pitchFamily="34" charset="-122"/>
                 <a:cs typeface="Calibri" pitchFamily="34" charset="-120"/>
               </a:rPr>
-              <a:t>   ngày) để so sánh growth giữa 2 kỳ.</a:t>
-            </a:r>
-          </a:p>
-          <a:p>
-            <a:pPr algn="l" indent="0" marL="0">
-              <a:buNone/>
-            </a:pPr>
-            <a:r>
-              <a:rPr lang="en-US" sz="1100" dirty="0" b="0">
-                <a:solidFill>
-                  <a:srgbClr val="5B6B7A"/>
-                </a:solidFill>
-                <a:latin typeface="Calibri" pitchFamily="34" charset="0"/>
-                <a:ea typeface="Calibri" pitchFamily="34" charset="-122"/>
-                <a:cs typeface="Calibri" pitchFamily="34" charset="-120"/>
-              </a:rPr>
-              <a:t>2) Demo dashboard DuckDB + Streamlit trực tiếp.</a:t>
-            </a:r>
-          </a:p>
-          <a:p>
-            <a:pPr algn="l" indent="0" marL="0">
-              <a:buNone/>
-            </a:pPr>
-            <a:r>
-              <a:rPr lang="en-US" sz="1100" dirty="0" b="0">
-                <a:solidFill>
-                  <a:srgbClr val="5B6B7A"/>
-                </a:solidFill>
-                <a:latin typeface="Calibri" pitchFamily="34" charset="0"/>
-                <a:ea typeface="Calibri" pitchFamily="34" charset="-122"/>
-                <a:cs typeface="Calibri" pitchFamily="34" charset="-120"/>
-              </a:rPr>
-              <a:t>3) Chốt đề cương Đồ án 3 (ML / nâng cao).</a:t>
-            </a:r>
-          </a:p>
-        </p:txBody>
-      </p:sp>
-      <p:sp>
-        <p:nvSpPr>
-          <p:cNvPr id="17" name="Text 15"/>
-          <p:cNvSpPr/>
-          <p:nvPr/>
-        </p:nvSpPr>
-        <p:spPr>
-          <a:xfrm>
-            <a:off x="777240" y="6053328"/>
-            <a:ext cx="10634472" cy="279202"/>
-          </a:xfrm>
-          <a:prstGeom prst="rect">
-            <a:avLst/>
-          </a:prstGeom>
-          <a:noFill/>
-          <a:ln/>
-        </p:spPr>
-        <p:txBody>
-          <a:bodyPr wrap="square" lIns="0" tIns="0" rIns="0" bIns="0" rtlCol="0" anchor="ctr">
-            <a:normAutofit/>
-          </a:bodyPr>
-          <a:lstStyle/>
-          <a:p>
-            <a:pPr algn="ctr" indent="0" marL="0">
-              <a:buNone/>
-            </a:pPr>
-            <a:r>
-              <a:rPr lang="en-US" sz="1700" b="0" dirty="0">
-                <a:solidFill>
-                  <a:srgbClr val="1D4ED8"/>
-                </a:solidFill>
-                <a:latin typeface="Calibri" pitchFamily="34" charset="0"/>
-                <a:ea typeface="Calibri" pitchFamily="34" charset="-122"/>
-                <a:cs typeface="Calibri" pitchFamily="34" charset="-120"/>
-              </a:rPr>
-              <a:t>DONE = evidence + commit + hiểu data flow</a:t>
-            </a:r>
-            <a:endParaRPr lang="en-US" sz="1800" dirty="0"/>
+              <a:t>2) Chốt đề cương Đồ án 3.</a:t>
+            </a:r>
           </a:p>
         </p:txBody>
       </p:sp>

</xml_diff>